<commit_message>
Added Presentation to project root folder and final commit message
</commit_message>
<xml_diff>
--- a/heart_disease_rap/Technical_Presentation.pptx
+++ b/heart_disease_rap/Technical_Presentation.pptx
@@ -4,6 +4,9 @@
   <p:sldMasterIdLst>
     <p:sldMasterId id="2147483648" r:id="rId1"/>
   </p:sldMasterIdLst>
+  <p:notesMasterIdLst>
+    <p:notesMasterId r:id="rId12"/>
+  </p:notesMasterIdLst>
   <p:sldIdLst>
     <p:sldId id="256" r:id="rId2"/>
     <p:sldId id="257" r:id="rId3"/>
@@ -16,9 +19,6 @@
     <p:sldId id="264" r:id="rId10"/>
     <p:sldId id="265" r:id="rId11"/>
   </p:sldIdLst>
-  <p:notesMasterIdLst>
-    <p:notesMasterId r:id="rId12"/>
-  </p:notesMasterIdLst>
   <p:sldSz cx="12192000" cy="6858000"/>
   <p:notesSz cx="6858000" cy="12192000"/>
   <p:defaultTextStyle>
@@ -113,7 +113,41 @@
       </a:defRPr>
     </a:lvl9pPr>
   </p:defaultTextStyle>
+  <p:extLst>
+    <p:ext uri="{EFAFB233-063F-42B5-8137-9DF3F51BA10A}">
+      <p15:sldGuideLst xmlns:p15="http://schemas.microsoft.com/office/powerpoint/2012/main"/>
+    </p:ext>
+  </p:extLst>
 </p:presentation>
+</file>
+
+<file path=ppt/changesInfos/changesInfo1.xml><?xml version="1.0" encoding="utf-8"?>
+<pc:chgInfo xmlns:a="http://schemas.openxmlformats.org/drawingml/2006/main" xmlns:r="http://schemas.openxmlformats.org/officeDocument/2006/relationships" xmlns:ac="http://schemas.microsoft.com/office/drawing/2013/main/command" xmlns:pc="http://schemas.microsoft.com/office/powerpoint/2013/main/command">
+  <pc:docChgLst>
+    <pc:chgData name="EWENIKE, Stan (NHS ENGLAND)" userId="40d65058-46a1-4874-b1ba-885e9a37a40a" providerId="ADAL" clId="{3ACB0511-6B68-40F3-A05C-46BD4C5D10B4}"/>
+    <pc:docChg chg="modSld">
+      <pc:chgData name="EWENIKE, Stan (NHS ENGLAND)" userId="40d65058-46a1-4874-b1ba-885e9a37a40a" providerId="ADAL" clId="{3ACB0511-6B68-40F3-A05C-46BD4C5D10B4}" dt="2026-04-20T15:03:35.951" v="6" actId="6549"/>
+      <pc:docMkLst>
+        <pc:docMk/>
+      </pc:docMkLst>
+      <pc:sldChg chg="modSp mod">
+        <pc:chgData name="EWENIKE, Stan (NHS ENGLAND)" userId="40d65058-46a1-4874-b1ba-885e9a37a40a" providerId="ADAL" clId="{3ACB0511-6B68-40F3-A05C-46BD4C5D10B4}" dt="2026-04-20T15:03:35.951" v="6" actId="6549"/>
+        <pc:sldMkLst>
+          <pc:docMk/>
+          <pc:sldMk cId="0" sldId="256"/>
+        </pc:sldMkLst>
+        <pc:spChg chg="mod">
+          <ac:chgData name="EWENIKE, Stan (NHS ENGLAND)" userId="40d65058-46a1-4874-b1ba-885e9a37a40a" providerId="ADAL" clId="{3ACB0511-6B68-40F3-A05C-46BD4C5D10B4}" dt="2026-04-20T15:03:35.951" v="6" actId="6549"/>
+          <ac:spMkLst>
+            <pc:docMk/>
+            <pc:sldMk cId="0" sldId="256"/>
+            <ac:spMk id="6" creationId="{00000000-0000-0000-0000-000000000000}"/>
+          </ac:spMkLst>
+        </pc:spChg>
+      </pc:sldChg>
+    </pc:docChg>
+  </pc:docChgLst>
+</pc:chgInfo>
 </file>
 
 <file path=ppt/notesMasters/notesMaster1.xml><?xml version="1.0" encoding="utf-8"?>
@@ -138,234 +172,10 @@
           <a:chExt cx="0" cy="0"/>
         </a:xfrm>
       </p:grpSpPr>
-      <p:sp>
-        <p:nvSpPr>
-          <p:cNvPr id="2" name="Header Placeholder 1"/>
-          <p:cNvSpPr>
-            <a:spLocks noGrp="1"/>
-          </p:cNvSpPr>
-          <p:nvPr>
-            <p:ph type="hdr" sz="quarter"/>
-          </p:nvPr>
-        </p:nvSpPr>
-        <p:spPr>
-          <a:xfrm>
-            <a:off x="0" y="0"/>
-            <a:ext cx="2971800" cy="458788"/>
-          </a:xfrm>
-          <a:prstGeom prst="rect">
-            <a:avLst/>
-          </a:prstGeom>
-        </p:spPr>
-        <p:txBody>
-          <a:bodyPr vert="horz" lIns="91440" tIns="45720" rIns="91440" bIns="45720" rtlCol="0"/>
-          <a:lstStyle>
-            <a:lvl1pPr algn="l">
-              <a:defRPr sz="1200"/>
-            </a:lvl1pPr>
-          </a:lstStyle>
-          <a:p>
-            <a:endParaRPr lang="en-US"/>
-          </a:p>
-        </p:txBody>
-      </p:sp>
-      <p:sp>
-        <p:nvSpPr>
-          <p:cNvPr id="3" name="Date Placeholder 2"/>
-          <p:cNvSpPr>
-            <a:spLocks noGrp="1"/>
-          </p:cNvSpPr>
-          <p:nvPr>
-            <p:ph type="dt" idx="1"/>
-          </p:nvPr>
-        </p:nvSpPr>
-        <p:spPr>
-          <a:xfrm>
-            <a:off x="3884613" y="0"/>
-            <a:ext cx="2971800" cy="458788"/>
-          </a:xfrm>
-          <a:prstGeom prst="rect">
-            <a:avLst/>
-          </a:prstGeom>
-        </p:spPr>
-        <p:txBody>
-          <a:bodyPr vert="horz" lIns="91440" tIns="45720" rIns="91440" bIns="45720" rtlCol="0"/>
-          <a:lstStyle>
-            <a:lvl1pPr algn="r">
-              <a:defRPr sz="1200"/>
-            </a:lvl1pPr>
-          </a:lstStyle>
-          <a:p>
-            <a:fld id="{5282F153-3F37-0F45-9E97-73ACFA13230C}" type="datetimeFigureOut">
-              <a:rPr lang="en-US"/>
-              <a:t>7/23/19</a:t>
-            </a:fld>
-            <a:endParaRPr lang="en-US"/>
-          </a:p>
-        </p:txBody>
-      </p:sp>
-      <p:sp>
-        <p:nvSpPr>
-          <p:cNvPr id="4" name="Slide Image Placeholder 3"/>
-          <p:cNvSpPr>
-            <a:spLocks noGrp="1" noRot="1" noChangeAspect="1"/>
-          </p:cNvSpPr>
-          <p:nvPr>
-            <p:ph type="sldImg" idx="2"/>
-          </p:nvPr>
-        </p:nvSpPr>
-        <p:spPr>
-          <a:xfrm>
-            <a:off x="685800" y="1143000"/>
-            <a:ext cx="5486400" cy="3086100"/>
-          </a:xfrm>
-          <a:prstGeom prst="rect">
-            <a:avLst/>
-          </a:prstGeom>
-          <a:noFill/>
-          <a:ln w="12700">
-            <a:solidFill>
-              <a:prstClr val="black"/>
-            </a:solidFill>
-          </a:ln>
-        </p:spPr>
-        <p:txBody>
-          <a:bodyPr vert="horz" lIns="91440" tIns="45720" rIns="91440" bIns="45720" rtlCol="0" anchor="ctr"/>
-          <a:lstStyle/>
-          <a:p>
-            <a:endParaRPr lang="en-US"/>
-          </a:p>
-        </p:txBody>
-      </p:sp>
-      <p:sp>
-        <p:nvSpPr>
-          <p:cNvPr id="5" name="Notes Placeholder 4"/>
-          <p:cNvSpPr>
-            <a:spLocks noGrp="1"/>
-          </p:cNvSpPr>
-          <p:nvPr>
-            <p:ph type="body" sz="quarter" idx="3"/>
-          </p:nvPr>
-        </p:nvSpPr>
-        <p:spPr>
-          <a:xfrm>
-            <a:off x="685800" y="4400550"/>
-            <a:ext cx="5486400" cy="3600450"/>
-          </a:xfrm>
-          <a:prstGeom prst="rect">
-            <a:avLst/>
-          </a:prstGeom>
-        </p:spPr>
-        <p:txBody>
-          <a:bodyPr vert="horz" lIns="91440" tIns="45720" rIns="91440" bIns="45720" rtlCol="0"/>
-          <a:lstStyle/>
-          <a:p>
-            <a:pPr lvl="0"/>
-            <a:r>
-              <a:rPr lang="en-US"/>
-              <a:t>Click to edit Master text styles</a:t>
-            </a:r>
-          </a:p>
-          <a:p>
-            <a:pPr lvl="1"/>
-            <a:r>
-              <a:rPr lang="en-US"/>
-              <a:t>Second level</a:t>
-            </a:r>
-          </a:p>
-          <a:p>
-            <a:pPr lvl="2"/>
-            <a:r>
-              <a:rPr lang="en-US"/>
-              <a:t>Third level</a:t>
-            </a:r>
-          </a:p>
-          <a:p>
-            <a:pPr lvl="3"/>
-            <a:r>
-              <a:rPr lang="en-US"/>
-              <a:t>Fourth level</a:t>
-            </a:r>
-          </a:p>
-          <a:p>
-            <a:pPr lvl="4"/>
-            <a:r>
-              <a:rPr lang="en-US"/>
-              <a:t>Fifth level</a:t>
-            </a:r>
-          </a:p>
-        </p:txBody>
-      </p:sp>
-      <p:sp>
-        <p:nvSpPr>
-          <p:cNvPr id="6" name="Footer Placeholder 5"/>
-          <p:cNvSpPr>
-            <a:spLocks noGrp="1"/>
-          </p:cNvSpPr>
-          <p:nvPr>
-            <p:ph type="ftr" sz="quarter" idx="4"/>
-          </p:nvPr>
-        </p:nvSpPr>
-        <p:spPr>
-          <a:xfrm>
-            <a:off x="0" y="8685213"/>
-            <a:ext cx="2971800" cy="458787"/>
-          </a:xfrm>
-          <a:prstGeom prst="rect">
-            <a:avLst/>
-          </a:prstGeom>
-        </p:spPr>
-        <p:txBody>
-          <a:bodyPr vert="horz" lIns="91440" tIns="45720" rIns="91440" bIns="45720" rtlCol="0" anchor="b"/>
-          <a:lstStyle>
-            <a:lvl1pPr algn="l">
-              <a:defRPr sz="1200"/>
-            </a:lvl1pPr>
-          </a:lstStyle>
-          <a:p>
-            <a:endParaRPr lang="en-US"/>
-          </a:p>
-        </p:txBody>
-      </p:sp>
-      <p:sp>
-        <p:nvSpPr>
-          <p:cNvPr id="7" name="Slide Number Placeholder 6"/>
-          <p:cNvSpPr>
-            <a:spLocks noGrp="1"/>
-          </p:cNvSpPr>
-          <p:nvPr>
-            <p:ph type="sldNum" sz="quarter" idx="5"/>
-          </p:nvPr>
-        </p:nvSpPr>
-        <p:spPr>
-          <a:xfrm>
-            <a:off x="3884613" y="8685213"/>
-            <a:ext cx="2971800" cy="458787"/>
-          </a:xfrm>
-          <a:prstGeom prst="rect">
-            <a:avLst/>
-          </a:prstGeom>
-        </p:spPr>
-        <p:txBody>
-          <a:bodyPr vert="horz" lIns="91440" tIns="45720" rIns="91440" bIns="45720" rtlCol="0" anchor="b"/>
-          <a:lstStyle>
-            <a:lvl1pPr algn="r">
-              <a:defRPr sz="1200"/>
-            </a:lvl1pPr>
-          </a:lstStyle>
-          <a:p>
-            <a:fld id="{CE5E9CC1-C706-0F49-92D6-E571CC5EEA8F}" type="slidenum">
-              <a:rPr lang="en-US"/>
-              <a:t>‹#›</a:t>
-            </a:fld>
-            <a:endParaRPr lang="en-US"/>
-          </a:p>
-        </p:txBody>
-      </p:sp>
     </p:spTree>
     <p:extLst>
       <p:ext uri="{BB962C8B-B14F-4D97-AF65-F5344CB8AC3E}">
-        <p14:creationId xmlns:p14="http://schemas.microsoft.com/office/powerpoint/2010/main" val="1024086991"/>
+        <p14:creationId xmlns:p14="http://schemas.microsoft.com/office/powerpoint/2010/main" val="305303191"/>
       </p:ext>
     </p:extLst>
   </p:cSld>
@@ -509,10 +319,6 @@
           <a:bodyPr/>
           <a:lstStyle/>
           <a:p>
-            <a:r>
-              <a:rPr lang="en-US" dirty="0"/>
-              <a:t/>
-            </a:r>
             <a:endParaRPr lang="en-US" dirty="0"/>
           </a:p>
         </p:txBody>
@@ -597,10 +403,6 @@
           <a:bodyPr/>
           <a:lstStyle/>
           <a:p>
-            <a:r>
-              <a:rPr lang="en-US" dirty="0"/>
-              <a:t/>
-            </a:r>
             <a:endParaRPr lang="en-US" dirty="0"/>
           </a:p>
         </p:txBody>
@@ -685,10 +487,6 @@
           <a:bodyPr/>
           <a:lstStyle/>
           <a:p>
-            <a:r>
-              <a:rPr lang="en-US" dirty="0"/>
-              <a:t/>
-            </a:r>
             <a:endParaRPr lang="en-US" dirty="0"/>
           </a:p>
         </p:txBody>
@@ -773,10 +571,6 @@
           <a:bodyPr/>
           <a:lstStyle/>
           <a:p>
-            <a:r>
-              <a:rPr lang="en-US" dirty="0"/>
-              <a:t/>
-            </a:r>
             <a:endParaRPr lang="en-US" dirty="0"/>
           </a:p>
         </p:txBody>
@@ -861,10 +655,6 @@
           <a:bodyPr/>
           <a:lstStyle/>
           <a:p>
-            <a:r>
-              <a:rPr lang="en-US" dirty="0"/>
-              <a:t/>
-            </a:r>
             <a:endParaRPr lang="en-US" dirty="0"/>
           </a:p>
         </p:txBody>
@@ -949,10 +739,6 @@
           <a:bodyPr/>
           <a:lstStyle/>
           <a:p>
-            <a:r>
-              <a:rPr lang="en-US" dirty="0"/>
-              <a:t/>
-            </a:r>
             <a:endParaRPr lang="en-US" dirty="0"/>
           </a:p>
         </p:txBody>
@@ -1037,10 +823,6 @@
           <a:bodyPr/>
           <a:lstStyle/>
           <a:p>
-            <a:r>
-              <a:rPr lang="en-US" dirty="0"/>
-              <a:t/>
-            </a:r>
             <a:endParaRPr lang="en-US" dirty="0"/>
           </a:p>
         </p:txBody>
@@ -1125,10 +907,6 @@
           <a:bodyPr/>
           <a:lstStyle/>
           <a:p>
-            <a:r>
-              <a:rPr lang="en-US" dirty="0"/>
-              <a:t/>
-            </a:r>
             <a:endParaRPr lang="en-US" dirty="0"/>
           </a:p>
         </p:txBody>
@@ -1213,10 +991,6 @@
           <a:bodyPr/>
           <a:lstStyle/>
           <a:p>
-            <a:r>
-              <a:rPr lang="en-US" dirty="0"/>
-              <a:t/>
-            </a:r>
             <a:endParaRPr lang="en-US" dirty="0"/>
           </a:p>
         </p:txBody>
@@ -1301,10 +1075,6 @@
           <a:bodyPr/>
           <a:lstStyle/>
           <a:p>
-            <a:r>
-              <a:rPr lang="en-US" dirty="0"/>
-              <a:t/>
-            </a:r>
             <a:endParaRPr lang="en-US" dirty="0"/>
           </a:p>
         </p:txBody>
@@ -1378,6 +1148,11 @@
 <file path=ppt/slideMasters/slideMaster1.xml><?xml version="1.0" encoding="utf-8"?>
 <p:sldMaster xmlns:a="http://schemas.openxmlformats.org/drawingml/2006/main" xmlns:r="http://schemas.openxmlformats.org/officeDocument/2006/relationships" xmlns:p="http://schemas.openxmlformats.org/presentationml/2006/main">
   <p:cSld>
+    <p:bg>
+      <p:bgRef idx="1001">
+        <a:schemeClr val="bg1"/>
+      </p:bgRef>
+    </p:bg>
     <p:spTree>
       <p:nvGrpSpPr>
         <p:cNvPr id="1" name=""/>
@@ -1660,6 +1435,7 @@
         <a:solidFill>
           <a:srgbClr val="0B2240"/>
         </a:solidFill>
+        <a:effectLst/>
       </p:bgPr>
     </p:bg>
     <p:spTree>
@@ -1695,6 +1471,13 @@
           </a:solidFill>
           <a:ln/>
         </p:spPr>
+        <p:txBody>
+          <a:bodyPr/>
+          <a:lstStyle/>
+          <a:p>
+            <a:endParaRPr lang="en-GB"/>
+          </a:p>
+        </p:txBody>
       </p:sp>
       <p:sp>
         <p:nvSpPr>
@@ -1717,7 +1500,7 @@
           <a:bodyPr wrap="square" lIns="0" tIns="0" rIns="0" bIns="0" rtlCol="0" anchor="ctr"/>
           <a:lstStyle/>
           <a:p>
-            <a:pPr indent="0" marL="0">
+            <a:pPr marL="0" indent="0">
               <a:buNone/>
             </a:pPr>
             <a:r>
@@ -1756,7 +1539,7 @@
           <a:bodyPr wrap="square" lIns="0" tIns="0" rIns="0" bIns="0" rtlCol="0" anchor="ctr"/>
           <a:lstStyle/>
           <a:p>
-            <a:pPr indent="0" marL="0">
+            <a:pPr marL="0" indent="0">
               <a:buNone/>
             </a:pPr>
             <a:r>
@@ -1796,6 +1579,13 @@
             <a:prstDash val="solid"/>
           </a:ln>
         </p:spPr>
+        <p:txBody>
+          <a:bodyPr/>
+          <a:lstStyle/>
+          <a:p>
+            <a:endParaRPr lang="en-GB"/>
+          </a:p>
+        </p:txBody>
       </p:sp>
       <p:sp>
         <p:nvSpPr>
@@ -1818,7 +1608,7 @@
           <a:bodyPr wrap="square" lIns="0" tIns="0" rIns="0" bIns="0" rtlCol="0" anchor="ctr"/>
           <a:lstStyle/>
           <a:p>
-            <a:pPr indent="0" marL="0">
+            <a:pPr marL="0" indent="0">
               <a:buNone/>
             </a:pPr>
             <a:r>
@@ -1830,24 +1620,7 @@
                 <a:ea typeface="Calibri" pitchFamily="34" charset="-122"/>
                 <a:cs typeface="Calibri" pitchFamily="34" charset="-120"/>
               </a:rPr>
-              <a:t>Stanley Ewenike, PhD</a:t>
-            </a:r>
-            <a:endParaRPr lang="en-US" sz="1800" dirty="0"/>
-          </a:p>
-          <a:p>
-            <a:pPr indent="0" marL="0">
-              <a:buNone/>
-            </a:pPr>
-            <a:r>
-              <a:rPr lang="en-US" sz="1400" dirty="0">
-                <a:solidFill>
-                  <a:srgbClr val="A8C3D6"/>
-                </a:solidFill>
-                <a:latin typeface="Calibri" pitchFamily="34" charset="0"/>
-                <a:ea typeface="Calibri" pitchFamily="34" charset="-122"/>
-                <a:cs typeface="Calibri" pitchFamily="34" charset="-120"/>
-              </a:rPr>
-              <a:t>NHS England Band 7 Data Scientist Technical Test</a:t>
+              <a:t>Stanley Ewenike</a:t>
             </a:r>
             <a:endParaRPr lang="en-US" sz="1800" dirty="0"/>
           </a:p>
@@ -1869,6 +1642,7 @@
         <a:solidFill>
           <a:srgbClr val="0B2240"/>
         </a:solidFill>
+        <a:effectLst/>
       </p:bgPr>
     </p:bg>
     <p:spTree>
@@ -1904,6 +1678,13 @@
           </a:solidFill>
           <a:ln/>
         </p:spPr>
+        <p:txBody>
+          <a:bodyPr/>
+          <a:lstStyle/>
+          <a:p>
+            <a:endParaRPr lang="en-GB"/>
+          </a:p>
+        </p:txBody>
       </p:sp>
       <p:sp>
         <p:nvSpPr>
@@ -1926,7 +1707,7 @@
           <a:bodyPr wrap="square" lIns="0" tIns="0" rIns="0" bIns="0" rtlCol="0" anchor="ctr"/>
           <a:lstStyle/>
           <a:p>
-            <a:pPr indent="0" marL="0">
+            <a:pPr marL="0" indent="0">
               <a:buNone/>
             </a:pPr>
             <a:r>
@@ -1965,7 +1746,7 @@
           <a:bodyPr wrap="square" lIns="0" tIns="0" rIns="0" bIns="0" rtlCol="0" anchor="ctr"/>
           <a:lstStyle/>
           <a:p>
-            <a:pPr indent="0" marL="0">
+            <a:pPr marL="0" indent="0">
               <a:spcAft>
                 <a:spcPts val="1400"/>
               </a:spcAft>
@@ -1985,7 +1766,7 @@
             <a:endParaRPr lang="en-US" sz="2000" dirty="0"/>
           </a:p>
           <a:p>
-            <a:pPr indent="0" marL="0">
+            <a:pPr marL="0" indent="0">
               <a:spcAft>
                 <a:spcPts val="1400"/>
               </a:spcAft>
@@ -2134,6 +1915,13 @@
             <a:prstDash val="solid"/>
           </a:ln>
         </p:spPr>
+        <p:txBody>
+          <a:bodyPr/>
+          <a:lstStyle/>
+          <a:p>
+            <a:endParaRPr lang="en-GB"/>
+          </a:p>
+        </p:txBody>
       </p:sp>
       <p:sp>
         <p:nvSpPr>
@@ -2156,7 +1944,7 @@
           <a:bodyPr wrap="square" lIns="0" tIns="0" rIns="0" bIns="0" rtlCol="0" anchor="ctr"/>
           <a:lstStyle/>
           <a:p>
-            <a:pPr indent="0" marL="0">
+            <a:pPr marL="0" indent="0">
               <a:buNone/>
             </a:pPr>
             <a:r>
@@ -2190,6 +1978,7 @@
         <a:solidFill>
           <a:srgbClr val="F4F7FA"/>
         </a:solidFill>
+        <a:effectLst/>
       </p:bgPr>
     </p:bg>
     <p:spTree>
@@ -2227,7 +2016,7 @@
           <a:bodyPr wrap="square" lIns="0" tIns="0" rIns="0" bIns="0" rtlCol="0" anchor="ctr"/>
           <a:lstStyle/>
           <a:p>
-            <a:pPr indent="0" marL="0">
+            <a:pPr marL="0" indent="0">
               <a:buNone/>
             </a:pPr>
             <a:r>
@@ -2266,7 +2055,7 @@
           <a:bodyPr wrap="square" lIns="0" tIns="0" rIns="0" bIns="0" rtlCol="0" anchor="ctr"/>
           <a:lstStyle/>
           <a:p>
-            <a:pPr indent="0" marL="0">
+            <a:pPr marL="0" indent="0">
               <a:buNone/>
             </a:pPr>
             <a:r>
@@ -2306,6 +2095,13 @@
             <a:prstDash val="solid"/>
           </a:ln>
         </p:spPr>
+        <p:txBody>
+          <a:bodyPr/>
+          <a:lstStyle/>
+          <a:p>
+            <a:endParaRPr lang="en-GB"/>
+          </a:p>
+        </p:txBody>
       </p:sp>
       <p:sp>
         <p:nvSpPr>
@@ -2331,13 +2127,20 @@
             <a:prstDash val="solid"/>
           </a:ln>
           <a:effectLst>
-            <a:outerShdw sx="100000" sy="100000" kx="0" ky="0" algn="bl" rotWithShape="0" blurRad="101600" dist="12700" dir="8100000">
+            <a:outerShdw blurRad="101600" dist="12700" dir="8100000" algn="bl" rotWithShape="0">
               <a:srgbClr val="000000">
                 <a:alpha val="8000"/>
               </a:srgbClr>
             </a:outerShdw>
           </a:effectLst>
         </p:spPr>
+        <p:txBody>
+          <a:bodyPr/>
+          <a:lstStyle/>
+          <a:p>
+            <a:endParaRPr lang="en-GB"/>
+          </a:p>
+        </p:txBody>
       </p:sp>
       <p:sp>
         <p:nvSpPr>
@@ -2360,7 +2163,7 @@
           <a:bodyPr wrap="square" lIns="0" tIns="0" rIns="0" bIns="0" rtlCol="0" anchor="ctr"/>
           <a:lstStyle/>
           <a:p>
-            <a:pPr indent="0" marL="0">
+            <a:pPr marL="0" indent="0">
               <a:buNone/>
             </a:pPr>
             <a:r>
@@ -2399,7 +2202,7 @@
           <a:bodyPr wrap="square" lIns="0" tIns="0" rIns="0" bIns="0" rtlCol="0" anchor="ctr"/>
           <a:lstStyle/>
           <a:p>
-            <a:pPr indent="0" marL="0">
+            <a:pPr marL="0" indent="0">
               <a:spcAft>
                 <a:spcPts val="1000"/>
               </a:spcAft>
@@ -2419,7 +2222,7 @@
             <a:endParaRPr lang="en-US" sz="1300" dirty="0"/>
           </a:p>
           <a:p>
-            <a:pPr indent="0" marL="0">
+            <a:pPr marL="0" indent="0">
               <a:spcAft>
                 <a:spcPts val="1000"/>
               </a:spcAft>
@@ -2439,7 +2242,7 @@
             <a:endParaRPr lang="en-US" sz="1300" dirty="0"/>
           </a:p>
           <a:p>
-            <a:pPr indent="0" marL="0">
+            <a:pPr marL="0" indent="0">
               <a:buNone/>
             </a:pPr>
             <a:r>
@@ -2478,7 +2281,7 @@
           <a:bodyPr wrap="square" lIns="0" tIns="0" rIns="0" bIns="0" rtlCol="0" anchor="ctr"/>
           <a:lstStyle/>
           <a:p>
-            <a:pPr indent="0" marL="0">
+            <a:pPr marL="0" indent="0">
               <a:buNone/>
             </a:pPr>
             <a:r>
@@ -2517,7 +2320,7 @@
           <a:bodyPr wrap="square" lIns="0" tIns="0" rIns="0" bIns="0" rtlCol="0" anchor="ctr"/>
           <a:lstStyle/>
           <a:p>
-            <a:pPr indent="0" marL="0">
+            <a:pPr marL="0" indent="0">
               <a:spcAft>
                 <a:spcPts val="600"/>
               </a:spcAft>
@@ -2537,7 +2340,7 @@
             <a:endParaRPr lang="en-US" sz="1300" dirty="0"/>
           </a:p>
           <a:p>
-            <a:pPr indent="0" marL="0">
+            <a:pPr marL="0" indent="0">
               <a:spcAft>
                 <a:spcPts val="600"/>
               </a:spcAft>
@@ -2557,7 +2360,7 @@
             <a:endParaRPr lang="en-US" sz="1300" dirty="0"/>
           </a:p>
           <a:p>
-            <a:pPr indent="0" marL="0">
+            <a:pPr marL="0" indent="0">
               <a:spcAft>
                 <a:spcPts val="600"/>
               </a:spcAft>
@@ -2577,7 +2380,7 @@
             <a:endParaRPr lang="en-US" sz="1300" dirty="0"/>
           </a:p>
           <a:p>
-            <a:pPr indent="0" marL="0">
+            <a:pPr marL="0" indent="0">
               <a:spcAft>
                 <a:spcPts val="600"/>
               </a:spcAft>
@@ -2597,7 +2400,7 @@
             <a:endParaRPr lang="en-US" sz="1300" dirty="0"/>
           </a:p>
           <a:p>
-            <a:pPr indent="0" marL="0">
+            <a:pPr marL="0" indent="0">
               <a:buNone/>
             </a:pPr>
             <a:r>
@@ -2639,13 +2442,20 @@
             <a:prstDash val="solid"/>
           </a:ln>
           <a:effectLst>
-            <a:outerShdw sx="100000" sy="100000" kx="0" ky="0" algn="bl" rotWithShape="0" blurRad="76200" dist="12700" dir="8100000">
+            <a:outerShdw blurRad="76200" dist="12700" dir="8100000" algn="bl" rotWithShape="0">
               <a:srgbClr val="000000">
                 <a:alpha val="8000"/>
               </a:srgbClr>
             </a:outerShdw>
           </a:effectLst>
         </p:spPr>
+        <p:txBody>
+          <a:bodyPr/>
+          <a:lstStyle/>
+          <a:p>
+            <a:endParaRPr lang="en-GB"/>
+          </a:p>
+        </p:txBody>
       </p:sp>
       <p:sp>
         <p:nvSpPr>
@@ -2666,6 +2476,13 @@
           </a:solidFill>
           <a:ln/>
         </p:spPr>
+        <p:txBody>
+          <a:bodyPr/>
+          <a:lstStyle/>
+          <a:p>
+            <a:endParaRPr lang="en-GB"/>
+          </a:p>
+        </p:txBody>
       </p:sp>
       <p:sp>
         <p:nvSpPr>
@@ -2688,7 +2505,7 @@
           <a:bodyPr wrap="square" lIns="0" tIns="0" rIns="0" bIns="0" rtlCol="0" anchor="ctr"/>
           <a:lstStyle/>
           <a:p>
-            <a:pPr algn="ctr" indent="0" marL="0">
+            <a:pPr marL="0" indent="0" algn="ctr">
               <a:buNone/>
             </a:pPr>
             <a:r>
@@ -2727,7 +2544,7 @@
           <a:bodyPr wrap="square" lIns="0" tIns="0" rIns="0" bIns="0" rtlCol="0" anchor="ctr"/>
           <a:lstStyle/>
           <a:p>
-            <a:pPr algn="ctr" indent="0" marL="0">
+            <a:pPr marL="0" indent="0" algn="ctr">
               <a:buNone/>
             </a:pPr>
             <a:r>
@@ -2766,7 +2583,7 @@
           <a:bodyPr wrap="square" lIns="0" tIns="0" rIns="0" bIns="0" rtlCol="0" anchor="ctr"/>
           <a:lstStyle/>
           <a:p>
-            <a:pPr algn="ctr" indent="0" marL="0">
+            <a:pPr marL="0" indent="0" algn="ctr">
               <a:buNone/>
             </a:pPr>
             <a:r>
@@ -2808,13 +2625,20 @@
             <a:prstDash val="solid"/>
           </a:ln>
           <a:effectLst>
-            <a:outerShdw sx="100000" sy="100000" kx="0" ky="0" algn="bl" rotWithShape="0" blurRad="76200" dist="12700" dir="8100000">
+            <a:outerShdw blurRad="76200" dist="12700" dir="8100000" algn="bl" rotWithShape="0">
               <a:srgbClr val="000000">
                 <a:alpha val="8000"/>
               </a:srgbClr>
             </a:outerShdw>
           </a:effectLst>
         </p:spPr>
+        <p:txBody>
+          <a:bodyPr/>
+          <a:lstStyle/>
+          <a:p>
+            <a:endParaRPr lang="en-GB"/>
+          </a:p>
+        </p:txBody>
       </p:sp>
       <p:sp>
         <p:nvSpPr>
@@ -2835,6 +2659,13 @@
           </a:solidFill>
           <a:ln/>
         </p:spPr>
+        <p:txBody>
+          <a:bodyPr/>
+          <a:lstStyle/>
+          <a:p>
+            <a:endParaRPr lang="en-GB"/>
+          </a:p>
+        </p:txBody>
       </p:sp>
       <p:sp>
         <p:nvSpPr>
@@ -2857,7 +2688,7 @@
           <a:bodyPr wrap="square" lIns="0" tIns="0" rIns="0" bIns="0" rtlCol="0" anchor="ctr"/>
           <a:lstStyle/>
           <a:p>
-            <a:pPr algn="ctr" indent="0" marL="0">
+            <a:pPr marL="0" indent="0" algn="ctr">
               <a:buNone/>
             </a:pPr>
             <a:r>
@@ -2896,7 +2727,7 @@
           <a:bodyPr wrap="square" lIns="0" tIns="0" rIns="0" bIns="0" rtlCol="0" anchor="ctr"/>
           <a:lstStyle/>
           <a:p>
-            <a:pPr algn="ctr" indent="0" marL="0">
+            <a:pPr marL="0" indent="0" algn="ctr">
               <a:buNone/>
             </a:pPr>
             <a:r>
@@ -2935,7 +2766,7 @@
           <a:bodyPr wrap="square" lIns="0" tIns="0" rIns="0" bIns="0" rtlCol="0" anchor="ctr"/>
           <a:lstStyle/>
           <a:p>
-            <a:pPr algn="ctr" indent="0" marL="0">
+            <a:pPr marL="0" indent="0" algn="ctr">
               <a:buNone/>
             </a:pPr>
             <a:r>
@@ -2977,13 +2808,20 @@
             <a:prstDash val="solid"/>
           </a:ln>
           <a:effectLst>
-            <a:outerShdw sx="100000" sy="100000" kx="0" ky="0" algn="bl" rotWithShape="0" blurRad="76200" dist="12700" dir="8100000">
+            <a:outerShdw blurRad="76200" dist="12700" dir="8100000" algn="bl" rotWithShape="0">
               <a:srgbClr val="000000">
                 <a:alpha val="8000"/>
               </a:srgbClr>
             </a:outerShdw>
           </a:effectLst>
         </p:spPr>
+        <p:txBody>
+          <a:bodyPr/>
+          <a:lstStyle/>
+          <a:p>
+            <a:endParaRPr lang="en-GB"/>
+          </a:p>
+        </p:txBody>
       </p:sp>
       <p:sp>
         <p:nvSpPr>
@@ -3004,6 +2842,13 @@
           </a:solidFill>
           <a:ln/>
         </p:spPr>
+        <p:txBody>
+          <a:bodyPr/>
+          <a:lstStyle/>
+          <a:p>
+            <a:endParaRPr lang="en-GB"/>
+          </a:p>
+        </p:txBody>
       </p:sp>
       <p:sp>
         <p:nvSpPr>
@@ -3026,7 +2871,7 @@
           <a:bodyPr wrap="square" lIns="0" tIns="0" rIns="0" bIns="0" rtlCol="0" anchor="ctr"/>
           <a:lstStyle/>
           <a:p>
-            <a:pPr algn="ctr" indent="0" marL="0">
+            <a:pPr marL="0" indent="0" algn="ctr">
               <a:buNone/>
             </a:pPr>
             <a:r>
@@ -3065,7 +2910,7 @@
           <a:bodyPr wrap="square" lIns="0" tIns="0" rIns="0" bIns="0" rtlCol="0" anchor="ctr"/>
           <a:lstStyle/>
           <a:p>
-            <a:pPr algn="ctr" indent="0" marL="0">
+            <a:pPr marL="0" indent="0" algn="ctr">
               <a:buNone/>
             </a:pPr>
             <a:r>
@@ -3104,7 +2949,7 @@
           <a:bodyPr wrap="square" lIns="0" tIns="0" rIns="0" bIns="0" rtlCol="0" anchor="ctr"/>
           <a:lstStyle/>
           <a:p>
-            <a:pPr algn="ctr" indent="0" marL="0">
+            <a:pPr marL="0" indent="0" algn="ctr">
               <a:buNone/>
             </a:pPr>
             <a:r>
@@ -3141,13 +2986,20 @@
           </a:solidFill>
           <a:ln/>
           <a:effectLst>
-            <a:outerShdw sx="100000" sy="100000" kx="0" ky="0" algn="bl" rotWithShape="0" blurRad="101600" dist="12700" dir="8100000">
+            <a:outerShdw blurRad="101600" dist="12700" dir="8100000" algn="bl" rotWithShape="0">
               <a:srgbClr val="000000">
                 <a:alpha val="15000"/>
               </a:srgbClr>
             </a:outerShdw>
           </a:effectLst>
         </p:spPr>
+        <p:txBody>
+          <a:bodyPr/>
+          <a:lstStyle/>
+          <a:p>
+            <a:endParaRPr lang="en-GB"/>
+          </a:p>
+        </p:txBody>
       </p:sp>
       <p:sp>
         <p:nvSpPr>
@@ -3168,6 +3020,13 @@
           </a:solidFill>
           <a:ln/>
         </p:spPr>
+        <p:txBody>
+          <a:bodyPr/>
+          <a:lstStyle/>
+          <a:p>
+            <a:endParaRPr lang="en-GB"/>
+          </a:p>
+        </p:txBody>
       </p:sp>
       <p:sp>
         <p:nvSpPr>
@@ -3190,7 +3049,7 @@
           <a:bodyPr wrap="square" lIns="0" tIns="0" rIns="0" bIns="0" rtlCol="0" anchor="ctr"/>
           <a:lstStyle/>
           <a:p>
-            <a:pPr indent="0" marL="0">
+            <a:pPr marL="0" indent="0">
               <a:buNone/>
             </a:pPr>
             <a:r>
@@ -3229,7 +3088,7 @@
           <a:bodyPr wrap="square" lIns="0" tIns="0" rIns="0" bIns="0" rtlCol="0" anchor="ctr"/>
           <a:lstStyle/>
           <a:p>
-            <a:pPr indent="0" marL="0">
+            <a:pPr marL="0" indent="0">
               <a:buNone/>
             </a:pPr>
             <a:r>
@@ -3268,7 +3127,7 @@
           <a:bodyPr wrap="square" lIns="0" tIns="0" rIns="0" bIns="0" rtlCol="0" anchor="ctr"/>
           <a:lstStyle/>
           <a:p>
-            <a:pPr indent="0" marL="0">
+            <a:pPr marL="0" indent="0">
               <a:buNone/>
             </a:pPr>
             <a:r>
@@ -3302,6 +3161,7 @@
         <a:solidFill>
           <a:srgbClr val="F4F7FA"/>
         </a:solidFill>
+        <a:effectLst/>
       </p:bgPr>
     </p:bg>
     <p:spTree>
@@ -3339,7 +3199,7 @@
           <a:bodyPr wrap="square" lIns="0" tIns="0" rIns="0" bIns="0" rtlCol="0" anchor="ctr"/>
           <a:lstStyle/>
           <a:p>
-            <a:pPr indent="0" marL="0">
+            <a:pPr marL="0" indent="0">
               <a:buNone/>
             </a:pPr>
             <a:r>
@@ -3378,7 +3238,7 @@
           <a:bodyPr wrap="square" lIns="0" tIns="0" rIns="0" bIns="0" rtlCol="0" anchor="ctr"/>
           <a:lstStyle/>
           <a:p>
-            <a:pPr indent="0" marL="0">
+            <a:pPr marL="0" indent="0">
               <a:buNone/>
             </a:pPr>
             <a:r>
@@ -3418,17 +3278,24 @@
             <a:prstDash val="solid"/>
           </a:ln>
         </p:spPr>
+        <p:txBody>
+          <a:bodyPr/>
+          <a:lstStyle/>
+          <a:p>
+            <a:endParaRPr lang="en-GB"/>
+          </a:p>
+        </p:txBody>
       </p:sp>
       <p:pic>
         <p:nvPicPr>
-          <p:cNvPr id="5" name="Image 0" descr="/home/claude/nhse_test/outputs/1_missingness.png">    </p:cNvPr>
+          <p:cNvPr id="5" name="Image 0" descr="/home/claude/nhse_test/outputs/1_missingness.png"/>
           <p:cNvPicPr>
             <a:picLocks noChangeAspect="1"/>
           </p:cNvPicPr>
           <p:nvPr/>
         </p:nvPicPr>
         <p:blipFill>
-          <a:blip r:embed="rId1"/>
+          <a:blip r:embed="rId3"/>
           <a:stretch>
             <a:fillRect/>
           </a:stretch>
@@ -3467,6 +3334,13 @@
             <a:prstDash val="solid"/>
           </a:ln>
         </p:spPr>
+        <p:txBody>
+          <a:bodyPr/>
+          <a:lstStyle/>
+          <a:p>
+            <a:endParaRPr lang="en-GB"/>
+          </a:p>
+        </p:txBody>
       </p:sp>
       <p:sp>
         <p:nvSpPr>
@@ -3489,7 +3363,7 @@
           <a:bodyPr wrap="square" lIns="0" tIns="0" rIns="0" bIns="0" rtlCol="0" anchor="ctr"/>
           <a:lstStyle/>
           <a:p>
-            <a:pPr indent="0" marL="0">
+            <a:pPr marL="0" indent="0">
               <a:buNone/>
             </a:pPr>
             <a:r>
@@ -3528,7 +3402,7 @@
           <a:bodyPr wrap="square" lIns="0" tIns="0" rIns="0" bIns="0" rtlCol="0" anchor="ctr"/>
           <a:lstStyle/>
           <a:p>
-            <a:pPr indent="0" marL="0">
+            <a:pPr marL="0" indent="0">
               <a:buNone/>
             </a:pPr>
             <a:r>
@@ -3545,7 +3419,7 @@
             <a:endParaRPr lang="en-US" sz="1300" dirty="0"/>
           </a:p>
           <a:p>
-            <a:pPr indent="0" marL="0">
+            <a:pPr marL="0" indent="0">
               <a:spcAft>
                 <a:spcPts val="800"/>
               </a:spcAft>
@@ -3565,7 +3439,7 @@
             <a:endParaRPr lang="en-US" sz="1300" dirty="0"/>
           </a:p>
           <a:p>
-            <a:pPr indent="0" marL="0">
+            <a:pPr marL="0" indent="0">
               <a:buNone/>
             </a:pPr>
             <a:r>
@@ -3582,7 +3456,7 @@
             <a:endParaRPr lang="en-US" sz="1300" dirty="0"/>
           </a:p>
           <a:p>
-            <a:pPr indent="0" marL="0">
+            <a:pPr marL="0" indent="0">
               <a:spcAft>
                 <a:spcPts val="800"/>
               </a:spcAft>
@@ -3602,7 +3476,7 @@
             <a:endParaRPr lang="en-US" sz="1300" dirty="0"/>
           </a:p>
           <a:p>
-            <a:pPr indent="0" marL="0">
+            <a:pPr marL="0" indent="0">
               <a:buNone/>
             </a:pPr>
             <a:r>
@@ -3619,7 +3493,7 @@
             <a:endParaRPr lang="en-US" sz="1300" dirty="0"/>
           </a:p>
           <a:p>
-            <a:pPr indent="0" marL="0">
+            <a:pPr marL="0" indent="0">
               <a:spcAft>
                 <a:spcPts val="800"/>
               </a:spcAft>
@@ -3639,7 +3513,7 @@
             <a:endParaRPr lang="en-US" sz="1300" dirty="0"/>
           </a:p>
           <a:p>
-            <a:pPr indent="0" marL="0">
+            <a:pPr marL="0" indent="0">
               <a:spcAft>
                 <a:spcPts val="800"/>
               </a:spcAft>
@@ -3659,7 +3533,7 @@
             <a:endParaRPr lang="en-US" sz="1300" dirty="0"/>
           </a:p>
           <a:p>
-            <a:pPr indent="0" marL="0">
+            <a:pPr marL="0" indent="0">
               <a:buNone/>
             </a:pPr>
             <a:r>
@@ -3676,7 +3550,7 @@
             <a:endParaRPr lang="en-US" sz="1300" dirty="0"/>
           </a:p>
           <a:p>
-            <a:pPr indent="0" marL="0">
+            <a:pPr marL="0" indent="0">
               <a:buNone/>
             </a:pPr>
             <a:r>
@@ -3710,6 +3584,7 @@
         <a:solidFill>
           <a:srgbClr val="F4F7FA"/>
         </a:solidFill>
+        <a:effectLst/>
       </p:bgPr>
     </p:bg>
     <p:spTree>
@@ -3747,7 +3622,7 @@
           <a:bodyPr wrap="square" lIns="0" tIns="0" rIns="0" bIns="0" rtlCol="0" anchor="ctr"/>
           <a:lstStyle/>
           <a:p>
-            <a:pPr indent="0" marL="0">
+            <a:pPr marL="0" indent="0">
               <a:buNone/>
             </a:pPr>
             <a:r>
@@ -3786,7 +3661,7 @@
           <a:bodyPr wrap="square" lIns="0" tIns="0" rIns="0" bIns="0" rtlCol="0" anchor="ctr"/>
           <a:lstStyle/>
           <a:p>
-            <a:pPr indent="0" marL="0">
+            <a:pPr marL="0" indent="0">
               <a:buNone/>
             </a:pPr>
             <a:r>
@@ -3826,17 +3701,24 @@
             <a:prstDash val="solid"/>
           </a:ln>
         </p:spPr>
+        <p:txBody>
+          <a:bodyPr/>
+          <a:lstStyle/>
+          <a:p>
+            <a:endParaRPr lang="en-GB"/>
+          </a:p>
+        </p:txBody>
       </p:sp>
       <p:pic>
         <p:nvPicPr>
-          <p:cNvPr id="5" name="Image 0" descr="/home/claude/nhse_test/outputs/2_prevalence_by_study.png">    </p:cNvPr>
+          <p:cNvPr id="5" name="Image 0" descr="/home/claude/nhse_test/outputs/2_prevalence_by_study.png"/>
           <p:cNvPicPr>
             <a:picLocks noChangeAspect="1"/>
           </p:cNvPicPr>
           <p:nvPr/>
         </p:nvPicPr>
         <p:blipFill>
-          <a:blip r:embed="rId1"/>
+          <a:blip r:embed="rId3"/>
           <a:stretch>
             <a:fillRect/>
           </a:stretch>
@@ -3875,6 +3757,13 @@
             <a:prstDash val="solid"/>
           </a:ln>
         </p:spPr>
+        <p:txBody>
+          <a:bodyPr/>
+          <a:lstStyle/>
+          <a:p>
+            <a:endParaRPr lang="en-GB"/>
+          </a:p>
+        </p:txBody>
       </p:sp>
       <p:sp>
         <p:nvSpPr>
@@ -3897,7 +3786,7 @@
           <a:bodyPr wrap="square" lIns="0" tIns="0" rIns="0" bIns="0" rtlCol="0" anchor="ctr"/>
           <a:lstStyle/>
           <a:p>
-            <a:pPr indent="0" marL="0">
+            <a:pPr marL="0" indent="0">
               <a:buNone/>
             </a:pPr>
             <a:r>
@@ -3936,7 +3825,7 @@
           <a:bodyPr wrap="square" lIns="0" tIns="0" rIns="0" bIns="0" rtlCol="0" anchor="ctr"/>
           <a:lstStyle/>
           <a:p>
-            <a:pPr indent="0" marL="0">
+            <a:pPr marL="0" indent="0">
               <a:spcAft>
                 <a:spcPts val="800"/>
               </a:spcAft>
@@ -3956,7 +3845,7 @@
             <a:endParaRPr lang="en-US" sz="1300" dirty="0"/>
           </a:p>
           <a:p>
-            <a:pPr indent="0" marL="0">
+            <a:pPr marL="0" indent="0">
               <a:spcAft>
                 <a:spcPts val="400"/>
               </a:spcAft>
@@ -3976,7 +3865,7 @@
             <a:endParaRPr lang="en-US" sz="1300" dirty="0"/>
           </a:p>
           <a:p>
-            <a:pPr indent="0" marL="0">
+            <a:pPr marL="0" indent="0">
               <a:spcAft>
                 <a:spcPts val="400"/>
               </a:spcAft>
@@ -3996,7 +3885,7 @@
             <a:endParaRPr lang="en-US" sz="1300" dirty="0"/>
           </a:p>
           <a:p>
-            <a:pPr indent="0" marL="0">
+            <a:pPr marL="0" indent="0">
               <a:spcAft>
                 <a:spcPts val="400"/>
               </a:spcAft>
@@ -4016,7 +3905,7 @@
             <a:endParaRPr lang="en-US" sz="1300" dirty="0"/>
           </a:p>
           <a:p>
-            <a:pPr indent="0" marL="0">
+            <a:pPr marL="0" indent="0">
               <a:spcAft>
                 <a:spcPts val="1000"/>
               </a:spcAft>
@@ -4036,7 +3925,7 @@
             <a:endParaRPr lang="en-US" sz="1300" dirty="0"/>
           </a:p>
           <a:p>
-            <a:pPr indent="0" marL="0">
+            <a:pPr marL="0" indent="0">
               <a:spcAft>
                 <a:spcPts val="600"/>
               </a:spcAft>
@@ -4056,7 +3945,7 @@
             <a:endParaRPr lang="en-US" sz="1300" dirty="0"/>
           </a:p>
           <a:p>
-            <a:pPr indent="0" marL="0">
+            <a:pPr marL="0" indent="0">
               <a:spcAft>
                 <a:spcPts val="800"/>
               </a:spcAft>
@@ -4076,7 +3965,7 @@
             <a:endParaRPr lang="en-US" sz="1300" dirty="0"/>
           </a:p>
           <a:p>
-            <a:pPr indent="0" marL="0">
+            <a:pPr marL="0" indent="0">
               <a:buNone/>
             </a:pPr>
             <a:r>
@@ -4110,6 +3999,7 @@
         <a:solidFill>
           <a:srgbClr val="F4F7FA"/>
         </a:solidFill>
+        <a:effectLst/>
       </p:bgPr>
     </p:bg>
     <p:spTree>
@@ -4147,7 +4037,7 @@
           <a:bodyPr wrap="square" lIns="0" tIns="0" rIns="0" bIns="0" rtlCol="0" anchor="ctr"/>
           <a:lstStyle/>
           <a:p>
-            <a:pPr indent="0" marL="0">
+            <a:pPr marL="0" indent="0">
               <a:buNone/>
             </a:pPr>
             <a:r>
@@ -4186,7 +4076,7 @@
           <a:bodyPr wrap="square" lIns="0" tIns="0" rIns="0" bIns="0" rtlCol="0" anchor="ctr"/>
           <a:lstStyle/>
           <a:p>
-            <a:pPr indent="0" marL="0">
+            <a:pPr marL="0" indent="0">
               <a:buNone/>
             </a:pPr>
             <a:r>
@@ -4226,6 +4116,13 @@
             <a:prstDash val="solid"/>
           </a:ln>
         </p:spPr>
+        <p:txBody>
+          <a:bodyPr/>
+          <a:lstStyle/>
+          <a:p>
+            <a:endParaRPr lang="en-GB"/>
+          </a:p>
+        </p:txBody>
       </p:sp>
       <p:sp>
         <p:nvSpPr>
@@ -4251,13 +4148,20 @@
             <a:prstDash val="solid"/>
           </a:ln>
           <a:effectLst>
-            <a:outerShdw sx="100000" sy="100000" kx="0" ky="0" algn="bl" rotWithShape="0" blurRad="76200" dist="12700" dir="8100000">
+            <a:outerShdw blurRad="76200" dist="12700" dir="8100000" algn="bl" rotWithShape="0">
               <a:srgbClr val="000000">
                 <a:alpha val="8000"/>
               </a:srgbClr>
             </a:outerShdw>
           </a:effectLst>
         </p:spPr>
+        <p:txBody>
+          <a:bodyPr/>
+          <a:lstStyle/>
+          <a:p>
+            <a:endParaRPr lang="en-GB"/>
+          </a:p>
+        </p:txBody>
       </p:sp>
       <p:sp>
         <p:nvSpPr>
@@ -4278,6 +4182,13 @@
           </a:solidFill>
           <a:ln/>
         </p:spPr>
+        <p:txBody>
+          <a:bodyPr/>
+          <a:lstStyle/>
+          <a:p>
+            <a:endParaRPr lang="en-GB"/>
+          </a:p>
+        </p:txBody>
       </p:sp>
       <p:sp>
         <p:nvSpPr>
@@ -4300,7 +4211,7 @@
           <a:bodyPr wrap="square" lIns="0" tIns="0" rIns="0" bIns="0" rtlCol="0" anchor="ctr"/>
           <a:lstStyle/>
           <a:p>
-            <a:pPr indent="0" marL="0">
+            <a:pPr marL="0" indent="0">
               <a:buNone/>
             </a:pPr>
             <a:r>
@@ -4339,7 +4250,7 @@
           <a:bodyPr wrap="square" lIns="0" tIns="0" rIns="0" bIns="0" rtlCol="0" anchor="ctr"/>
           <a:lstStyle/>
           <a:p>
-            <a:pPr indent="0" marL="0">
+            <a:pPr marL="0" indent="0">
               <a:buNone/>
             </a:pPr>
             <a:r>
@@ -4378,7 +4289,7 @@
           <a:bodyPr wrap="square" lIns="0" tIns="0" rIns="0" bIns="0" rtlCol="0" anchor="ctr"/>
           <a:lstStyle/>
           <a:p>
-            <a:pPr indent="0" marL="0">
+            <a:pPr marL="0" indent="0">
               <a:buNone/>
             </a:pPr>
             <a:r>
@@ -4420,13 +4331,20 @@
             <a:prstDash val="solid"/>
           </a:ln>
           <a:effectLst>
-            <a:outerShdw sx="100000" sy="100000" kx="0" ky="0" algn="bl" rotWithShape="0" blurRad="76200" dist="12700" dir="8100000">
+            <a:outerShdw blurRad="76200" dist="12700" dir="8100000" algn="bl" rotWithShape="0">
               <a:srgbClr val="000000">
                 <a:alpha val="8000"/>
               </a:srgbClr>
             </a:outerShdw>
           </a:effectLst>
         </p:spPr>
+        <p:txBody>
+          <a:bodyPr/>
+          <a:lstStyle/>
+          <a:p>
+            <a:endParaRPr lang="en-GB"/>
+          </a:p>
+        </p:txBody>
       </p:sp>
       <p:sp>
         <p:nvSpPr>
@@ -4447,6 +4365,13 @@
           </a:solidFill>
           <a:ln/>
         </p:spPr>
+        <p:txBody>
+          <a:bodyPr/>
+          <a:lstStyle/>
+          <a:p>
+            <a:endParaRPr lang="en-GB"/>
+          </a:p>
+        </p:txBody>
       </p:sp>
       <p:sp>
         <p:nvSpPr>
@@ -4469,7 +4394,7 @@
           <a:bodyPr wrap="square" lIns="0" tIns="0" rIns="0" bIns="0" rtlCol="0" anchor="ctr"/>
           <a:lstStyle/>
           <a:p>
-            <a:pPr indent="0" marL="0">
+            <a:pPr marL="0" indent="0">
               <a:buNone/>
             </a:pPr>
             <a:r>
@@ -4508,7 +4433,7 @@
           <a:bodyPr wrap="square" lIns="0" tIns="0" rIns="0" bIns="0" rtlCol="0" anchor="ctr"/>
           <a:lstStyle/>
           <a:p>
-            <a:pPr indent="0" marL="0">
+            <a:pPr marL="0" indent="0">
               <a:buNone/>
             </a:pPr>
             <a:r>
@@ -4547,7 +4472,7 @@
           <a:bodyPr wrap="square" lIns="0" tIns="0" rIns="0" bIns="0" rtlCol="0" anchor="ctr"/>
           <a:lstStyle/>
           <a:p>
-            <a:pPr indent="0" marL="0">
+            <a:pPr marL="0" indent="0">
               <a:buNone/>
             </a:pPr>
             <a:r>
@@ -4589,13 +4514,20 @@
             <a:prstDash val="solid"/>
           </a:ln>
           <a:effectLst>
-            <a:outerShdw sx="100000" sy="100000" kx="0" ky="0" algn="bl" rotWithShape="0" blurRad="76200" dist="12700" dir="8100000">
+            <a:outerShdw blurRad="76200" dist="12700" dir="8100000" algn="bl" rotWithShape="0">
               <a:srgbClr val="000000">
                 <a:alpha val="8000"/>
               </a:srgbClr>
             </a:outerShdw>
           </a:effectLst>
         </p:spPr>
+        <p:txBody>
+          <a:bodyPr/>
+          <a:lstStyle/>
+          <a:p>
+            <a:endParaRPr lang="en-GB"/>
+          </a:p>
+        </p:txBody>
       </p:sp>
       <p:sp>
         <p:nvSpPr>
@@ -4616,6 +4548,13 @@
           </a:solidFill>
           <a:ln/>
         </p:spPr>
+        <p:txBody>
+          <a:bodyPr/>
+          <a:lstStyle/>
+          <a:p>
+            <a:endParaRPr lang="en-GB"/>
+          </a:p>
+        </p:txBody>
       </p:sp>
       <p:sp>
         <p:nvSpPr>
@@ -4638,7 +4577,7 @@
           <a:bodyPr wrap="square" lIns="0" tIns="0" rIns="0" bIns="0" rtlCol="0" anchor="ctr"/>
           <a:lstStyle/>
           <a:p>
-            <a:pPr indent="0" marL="0">
+            <a:pPr marL="0" indent="0">
               <a:buNone/>
             </a:pPr>
             <a:r>
@@ -4677,7 +4616,7 @@
           <a:bodyPr wrap="square" lIns="0" tIns="0" rIns="0" bIns="0" rtlCol="0" anchor="ctr"/>
           <a:lstStyle/>
           <a:p>
-            <a:pPr indent="0" marL="0">
+            <a:pPr marL="0" indent="0">
               <a:buNone/>
             </a:pPr>
             <a:r>
@@ -4716,7 +4655,7 @@
           <a:bodyPr wrap="square" lIns="0" tIns="0" rIns="0" bIns="0" rtlCol="0" anchor="ctr"/>
           <a:lstStyle/>
           <a:p>
-            <a:pPr indent="0" marL="0">
+            <a:pPr marL="0" indent="0">
               <a:buNone/>
             </a:pPr>
             <a:r>
@@ -4758,13 +4697,20 @@
             <a:prstDash val="solid"/>
           </a:ln>
           <a:effectLst>
-            <a:outerShdw sx="100000" sy="100000" kx="0" ky="0" algn="bl" rotWithShape="0" blurRad="76200" dist="12700" dir="8100000">
+            <a:outerShdw blurRad="76200" dist="12700" dir="8100000" algn="bl" rotWithShape="0">
               <a:srgbClr val="000000">
                 <a:alpha val="8000"/>
               </a:srgbClr>
             </a:outerShdw>
           </a:effectLst>
         </p:spPr>
+        <p:txBody>
+          <a:bodyPr/>
+          <a:lstStyle/>
+          <a:p>
+            <a:endParaRPr lang="en-GB"/>
+          </a:p>
+        </p:txBody>
       </p:sp>
       <p:sp>
         <p:nvSpPr>
@@ -4785,6 +4731,13 @@
           </a:solidFill>
           <a:ln/>
         </p:spPr>
+        <p:txBody>
+          <a:bodyPr/>
+          <a:lstStyle/>
+          <a:p>
+            <a:endParaRPr lang="en-GB"/>
+          </a:p>
+        </p:txBody>
       </p:sp>
       <p:sp>
         <p:nvSpPr>
@@ -4807,7 +4760,7 @@
           <a:bodyPr wrap="square" lIns="0" tIns="0" rIns="0" bIns="0" rtlCol="0" anchor="ctr"/>
           <a:lstStyle/>
           <a:p>
-            <a:pPr indent="0" marL="0">
+            <a:pPr marL="0" indent="0">
               <a:buNone/>
             </a:pPr>
             <a:r>
@@ -4846,7 +4799,7 @@
           <a:bodyPr wrap="square" lIns="0" tIns="0" rIns="0" bIns="0" rtlCol="0" anchor="ctr"/>
           <a:lstStyle/>
           <a:p>
-            <a:pPr indent="0" marL="0">
+            <a:pPr marL="0" indent="0">
               <a:buNone/>
             </a:pPr>
             <a:r>
@@ -4885,7 +4838,7 @@
           <a:bodyPr wrap="square" lIns="0" tIns="0" rIns="0" bIns="0" rtlCol="0" anchor="ctr"/>
           <a:lstStyle/>
           <a:p>
-            <a:pPr indent="0" marL="0">
+            <a:pPr marL="0" indent="0">
               <a:buNone/>
             </a:pPr>
             <a:r>
@@ -4919,6 +4872,7 @@
         <a:solidFill>
           <a:srgbClr val="F4F7FA"/>
         </a:solidFill>
+        <a:effectLst/>
       </p:bgPr>
     </p:bg>
     <p:spTree>
@@ -4956,7 +4910,7 @@
           <a:bodyPr wrap="square" lIns="0" tIns="0" rIns="0" bIns="0" rtlCol="0" anchor="ctr"/>
           <a:lstStyle/>
           <a:p>
-            <a:pPr indent="0" marL="0">
+            <a:pPr marL="0" indent="0">
               <a:buNone/>
             </a:pPr>
             <a:r>
@@ -4995,7 +4949,7 @@
           <a:bodyPr wrap="square" lIns="0" tIns="0" rIns="0" bIns="0" rtlCol="0" anchor="ctr"/>
           <a:lstStyle/>
           <a:p>
-            <a:pPr indent="0" marL="0">
+            <a:pPr marL="0" indent="0">
               <a:buNone/>
             </a:pPr>
             <a:r>
@@ -5035,6 +4989,13 @@
             <a:prstDash val="solid"/>
           </a:ln>
         </p:spPr>
+        <p:txBody>
+          <a:bodyPr/>
+          <a:lstStyle/>
+          <a:p>
+            <a:endParaRPr lang="en-GB"/>
+          </a:p>
+        </p:txBody>
       </p:sp>
       <p:sp>
         <p:nvSpPr>
@@ -5055,13 +5016,20 @@
           </a:solidFill>
           <a:ln/>
           <a:effectLst>
-            <a:outerShdw sx="100000" sy="100000" kx="0" ky="0" algn="bl" rotWithShape="0" blurRad="101600" dist="12700" dir="8100000">
+            <a:outerShdw blurRad="101600" dist="12700" dir="8100000" algn="bl" rotWithShape="0">
               <a:srgbClr val="000000">
                 <a:alpha val="20000"/>
               </a:srgbClr>
             </a:outerShdw>
           </a:effectLst>
         </p:spPr>
+        <p:txBody>
+          <a:bodyPr/>
+          <a:lstStyle/>
+          <a:p>
+            <a:endParaRPr lang="en-GB"/>
+          </a:p>
+        </p:txBody>
       </p:sp>
       <p:sp>
         <p:nvSpPr>
@@ -5084,7 +5052,7 @@
           <a:bodyPr wrap="square" lIns="0" tIns="0" rIns="0" bIns="0" rtlCol="0" anchor="ctr"/>
           <a:lstStyle/>
           <a:p>
-            <a:pPr indent="0" marL="0">
+            <a:pPr marL="0" indent="0">
               <a:buNone/>
             </a:pPr>
             <a:r>
@@ -5123,7 +5091,7 @@
           <a:bodyPr wrap="square" lIns="0" tIns="0" rIns="0" bIns="0" rtlCol="0" anchor="ctr"/>
           <a:lstStyle/>
           <a:p>
-            <a:pPr indent="0" marL="0">
+            <a:pPr marL="0" indent="0">
               <a:buNone/>
             </a:pPr>
             <a:r>
@@ -5140,7 +5108,7 @@
             <a:endParaRPr lang="en-US" sz="1200" dirty="0"/>
           </a:p>
           <a:p>
-            <a:pPr indent="0" marL="0">
+            <a:pPr marL="0" indent="0">
               <a:buNone/>
             </a:pPr>
             <a:r>
@@ -5154,9 +5122,6 @@
               </a:rPr>
               <a:t>  config.yaml           </a:t>
             </a:r>
-            <a:pPr indent="0" marL="0">
-              <a:buNone/>
-            </a:pPr>
             <a:r>
               <a:rPr lang="en-US" sz="1100" dirty="0">
                 <a:solidFill>
@@ -5171,7 +5136,7 @@
             <a:endParaRPr lang="en-US" sz="1200" dirty="0"/>
           </a:p>
           <a:p>
-            <a:pPr indent="0" marL="0">
+            <a:pPr marL="0" indent="0">
               <a:buNone/>
             </a:pPr>
             <a:r>
@@ -5185,9 +5150,6 @@
               </a:rPr>
               <a:t>  main.py               </a:t>
             </a:r>
-            <a:pPr indent="0" marL="0">
-              <a:buNone/>
-            </a:pPr>
             <a:r>
               <a:rPr lang="en-US" sz="1100" dirty="0">
                 <a:solidFill>
@@ -5202,7 +5164,7 @@
             <a:endParaRPr lang="en-US" sz="1200" dirty="0"/>
           </a:p>
           <a:p>
-            <a:pPr indent="0" marL="0">
+            <a:pPr marL="0" indent="0">
               <a:buNone/>
             </a:pPr>
             <a:r>
@@ -5219,7 +5181,7 @@
             <a:endParaRPr lang="en-US" sz="1200" dirty="0"/>
           </a:p>
           <a:p>
-            <a:pPr indent="0" marL="0">
+            <a:pPr marL="0" indent="0">
               <a:buNone/>
             </a:pPr>
             <a:r>
@@ -5236,7 +5198,7 @@
             <a:endParaRPr lang="en-US" sz="1200" dirty="0"/>
           </a:p>
           <a:p>
-            <a:pPr indent="0" marL="0">
+            <a:pPr marL="0" indent="0">
               <a:buNone/>
             </a:pPr>
             <a:r>
@@ -5253,7 +5215,7 @@
             <a:endParaRPr lang="en-US" sz="1200" dirty="0"/>
           </a:p>
           <a:p>
-            <a:pPr indent="0" marL="0">
+            <a:pPr marL="0" indent="0">
               <a:buNone/>
             </a:pPr>
             <a:r>
@@ -5270,7 +5232,7 @@
             <a:endParaRPr lang="en-US" sz="1200" dirty="0"/>
           </a:p>
           <a:p>
-            <a:pPr indent="0" marL="0">
+            <a:pPr marL="0" indent="0">
               <a:buNone/>
             </a:pPr>
             <a:r>
@@ -5284,9 +5246,6 @@
               </a:rPr>
               <a:t>    data_loader.py      </a:t>
             </a:r>
-            <a:pPr indent="0" marL="0">
-              <a:buNone/>
-            </a:pPr>
             <a:r>
               <a:rPr lang="en-US" sz="1100" dirty="0">
                 <a:solidFill>
@@ -5301,7 +5260,7 @@
             <a:endParaRPr lang="en-US" sz="1200" dirty="0"/>
           </a:p>
           <a:p>
-            <a:pPr indent="0" marL="0">
+            <a:pPr marL="0" indent="0">
               <a:buNone/>
             </a:pPr>
             <a:r>
@@ -5315,9 +5274,6 @@
               </a:rPr>
               <a:t>    eda.py              </a:t>
             </a:r>
-            <a:pPr indent="0" marL="0">
-              <a:buNone/>
-            </a:pPr>
             <a:r>
               <a:rPr lang="en-US" sz="1100" dirty="0">
                 <a:solidFill>
@@ -5332,7 +5288,7 @@
             <a:endParaRPr lang="en-US" sz="1200" dirty="0"/>
           </a:p>
           <a:p>
-            <a:pPr indent="0" marL="0">
+            <a:pPr marL="0" indent="0">
               <a:buNone/>
             </a:pPr>
             <a:r>
@@ -5346,9 +5302,6 @@
               </a:rPr>
               <a:t>    preprocess.py       </a:t>
             </a:r>
-            <a:pPr indent="0" marL="0">
-              <a:buNone/>
-            </a:pPr>
             <a:r>
               <a:rPr lang="en-US" sz="1100" dirty="0">
                 <a:solidFill>
@@ -5363,7 +5316,7 @@
             <a:endParaRPr lang="en-US" sz="1200" dirty="0"/>
           </a:p>
           <a:p>
-            <a:pPr indent="0" marL="0">
+            <a:pPr marL="0" indent="0">
               <a:buNone/>
             </a:pPr>
             <a:r>
@@ -5377,9 +5330,6 @@
               </a:rPr>
               <a:t>    train.py            </a:t>
             </a:r>
-            <a:pPr indent="0" marL="0">
-              <a:buNone/>
-            </a:pPr>
             <a:r>
               <a:rPr lang="en-US" sz="1100" dirty="0">
                 <a:solidFill>
@@ -5394,7 +5344,7 @@
             <a:endParaRPr lang="en-US" sz="1200" dirty="0"/>
           </a:p>
           <a:p>
-            <a:pPr indent="0" marL="0">
+            <a:pPr marL="0" indent="0">
               <a:buNone/>
             </a:pPr>
             <a:r>
@@ -5408,9 +5358,6 @@
               </a:rPr>
               <a:t>    evaluate.py         </a:t>
             </a:r>
-            <a:pPr indent="0" marL="0">
-              <a:buNone/>
-            </a:pPr>
             <a:r>
               <a:rPr lang="en-US" sz="1100" dirty="0">
                 <a:solidFill>
@@ -5425,7 +5372,7 @@
             <a:endParaRPr lang="en-US" sz="1200" dirty="0"/>
           </a:p>
           <a:p>
-            <a:pPr indent="0" marL="0">
+            <a:pPr marL="0" indent="0">
               <a:buNone/>
             </a:pPr>
             <a:r>
@@ -5442,7 +5389,7 @@
             <a:endParaRPr lang="en-US" sz="1200" dirty="0"/>
           </a:p>
           <a:p>
-            <a:pPr indent="0" marL="0">
+            <a:pPr marL="0" indent="0">
               <a:buNone/>
             </a:pPr>
             <a:r>
@@ -5456,9 +5403,6 @@
               </a:rPr>
               <a:t>    test_pipeline.py    </a:t>
             </a:r>
-            <a:pPr indent="0" marL="0">
-              <a:buNone/>
-            </a:pPr>
             <a:r>
               <a:rPr lang="en-US" sz="1100" dirty="0">
                 <a:solidFill>
@@ -5473,7 +5417,7 @@
             <a:endParaRPr lang="en-US" sz="1200" dirty="0"/>
           </a:p>
           <a:p>
-            <a:pPr indent="0" marL="0">
+            <a:pPr marL="0" indent="0">
               <a:buNone/>
             </a:pPr>
             <a:r>
@@ -5490,7 +5434,7 @@
             <a:endParaRPr lang="en-US" sz="1200" dirty="0"/>
           </a:p>
           <a:p>
-            <a:pPr indent="0" marL="0">
+            <a:pPr marL="0" indent="0">
               <a:buNone/>
             </a:pPr>
             <a:r>
@@ -5504,9 +5448,6 @@
               </a:rPr>
               <a:t>  outputs/              </a:t>
             </a:r>
-            <a:pPr indent="0" marL="0">
-              <a:buNone/>
-            </a:pPr>
             <a:r>
               <a:rPr lang="en-US" sz="1100" dirty="0">
                 <a:solidFill>
@@ -5546,6 +5487,13 @@
             <a:prstDash val="solid"/>
           </a:ln>
         </p:spPr>
+        <p:txBody>
+          <a:bodyPr/>
+          <a:lstStyle/>
+          <a:p>
+            <a:endParaRPr lang="en-GB"/>
+          </a:p>
+        </p:txBody>
       </p:sp>
       <p:sp>
         <p:nvSpPr>
@@ -5568,7 +5516,7 @@
           <a:bodyPr wrap="square" lIns="0" tIns="0" rIns="0" bIns="0" rtlCol="0" anchor="ctr"/>
           <a:lstStyle/>
           <a:p>
-            <a:pPr indent="0" marL="0">
+            <a:pPr marL="0" indent="0">
               <a:buNone/>
             </a:pPr>
             <a:r>
@@ -5607,7 +5555,7 @@
           <a:bodyPr wrap="square" lIns="0" tIns="0" rIns="0" bIns="0" rtlCol="0" anchor="ctr"/>
           <a:lstStyle/>
           <a:p>
-            <a:pPr indent="0" marL="0">
+            <a:pPr marL="0" indent="0">
               <a:buNone/>
             </a:pPr>
             <a:r>
@@ -5624,7 +5572,7 @@
             <a:endParaRPr lang="en-US" sz="1200" dirty="0"/>
           </a:p>
           <a:p>
-            <a:pPr indent="0" marL="0">
+            <a:pPr marL="0" indent="0">
               <a:spcAft>
                 <a:spcPts val="600"/>
               </a:spcAft>
@@ -5644,7 +5592,7 @@
             <a:endParaRPr lang="en-US" sz="1200" dirty="0"/>
           </a:p>
           <a:p>
-            <a:pPr indent="0" marL="0">
+            <a:pPr marL="0" indent="0">
               <a:buNone/>
             </a:pPr>
             <a:r>
@@ -5661,7 +5609,7 @@
             <a:endParaRPr lang="en-US" sz="1200" dirty="0"/>
           </a:p>
           <a:p>
-            <a:pPr indent="0" marL="0">
+            <a:pPr marL="0" indent="0">
               <a:spcAft>
                 <a:spcPts val="600"/>
               </a:spcAft>
@@ -5681,7 +5629,7 @@
             <a:endParaRPr lang="en-US" sz="1200" dirty="0"/>
           </a:p>
           <a:p>
-            <a:pPr indent="0" marL="0">
+            <a:pPr marL="0" indent="0">
               <a:buNone/>
             </a:pPr>
             <a:r>
@@ -5698,7 +5646,7 @@
             <a:endParaRPr lang="en-US" sz="1200" dirty="0"/>
           </a:p>
           <a:p>
-            <a:pPr indent="0" marL="0">
+            <a:pPr marL="0" indent="0">
               <a:spcAft>
                 <a:spcPts val="600"/>
               </a:spcAft>
@@ -5718,7 +5666,7 @@
             <a:endParaRPr lang="en-US" sz="1200" dirty="0"/>
           </a:p>
           <a:p>
-            <a:pPr indent="0" marL="0">
+            <a:pPr marL="0" indent="0">
               <a:buNone/>
             </a:pPr>
             <a:r>
@@ -5735,7 +5683,7 @@
             <a:endParaRPr lang="en-US" sz="1200" dirty="0"/>
           </a:p>
           <a:p>
-            <a:pPr indent="0" marL="0">
+            <a:pPr marL="0" indent="0">
               <a:spcAft>
                 <a:spcPts val="600"/>
               </a:spcAft>
@@ -5755,7 +5703,7 @@
             <a:endParaRPr lang="en-US" sz="1200" dirty="0"/>
           </a:p>
           <a:p>
-            <a:pPr indent="0" marL="0">
+            <a:pPr marL="0" indent="0">
               <a:buNone/>
             </a:pPr>
             <a:r>
@@ -5772,7 +5720,7 @@
             <a:endParaRPr lang="en-US" sz="1200" dirty="0"/>
           </a:p>
           <a:p>
-            <a:pPr indent="0" marL="0">
+            <a:pPr marL="0" indent="0">
               <a:spcAft>
                 <a:spcPts val="600"/>
               </a:spcAft>
@@ -5792,7 +5740,7 @@
             <a:endParaRPr lang="en-US" sz="1200" dirty="0"/>
           </a:p>
           <a:p>
-            <a:pPr indent="0" marL="0">
+            <a:pPr marL="0" indent="0">
               <a:buNone/>
             </a:pPr>
             <a:r>
@@ -5809,7 +5757,7 @@
             <a:endParaRPr lang="en-US" sz="1200" dirty="0"/>
           </a:p>
           <a:p>
-            <a:pPr indent="0" marL="0">
+            <a:pPr marL="0" indent="0">
               <a:buNone/>
             </a:pPr>
             <a:r>
@@ -5843,6 +5791,7 @@
         <a:solidFill>
           <a:srgbClr val="F4F7FA"/>
         </a:solidFill>
+        <a:effectLst/>
       </p:bgPr>
     </p:bg>
     <p:spTree>
@@ -5880,7 +5829,7 @@
           <a:bodyPr wrap="square" lIns="0" tIns="0" rIns="0" bIns="0" rtlCol="0" anchor="ctr"/>
           <a:lstStyle/>
           <a:p>
-            <a:pPr indent="0" marL="0">
+            <a:pPr marL="0" indent="0">
               <a:buNone/>
             </a:pPr>
             <a:r>
@@ -5919,7 +5868,7 @@
           <a:bodyPr wrap="square" lIns="0" tIns="0" rIns="0" bIns="0" rtlCol="0" anchor="ctr"/>
           <a:lstStyle/>
           <a:p>
-            <a:pPr indent="0" marL="0">
+            <a:pPr marL="0" indent="0">
               <a:buNone/>
             </a:pPr>
             <a:r>
@@ -5959,17 +5908,24 @@
             <a:prstDash val="solid"/>
           </a:ln>
         </p:spPr>
+        <p:txBody>
+          <a:bodyPr/>
+          <a:lstStyle/>
+          <a:p>
+            <a:endParaRPr lang="en-GB"/>
+          </a:p>
+        </p:txBody>
       </p:sp>
       <p:pic>
         <p:nvPicPr>
-          <p:cNvPr id="5" name="Image 0" descr="/home/claude/nhse_test/outputs/3_roc_curve.png">    </p:cNvPr>
+          <p:cNvPr id="5" name="Image 0" descr="/home/claude/nhse_test/outputs/3_roc_curve.png"/>
           <p:cNvPicPr>
             <a:picLocks noChangeAspect="1"/>
           </p:cNvPicPr>
           <p:nvPr/>
         </p:nvPicPr>
         <p:blipFill>
-          <a:blip r:embed="rId1"/>
+          <a:blip r:embed="rId3"/>
           <a:stretch>
             <a:fillRect/>
           </a:stretch>
@@ -6008,6 +5964,13 @@
             <a:prstDash val="solid"/>
           </a:ln>
         </p:spPr>
+        <p:txBody>
+          <a:bodyPr/>
+          <a:lstStyle/>
+          <a:p>
+            <a:endParaRPr lang="en-GB"/>
+          </a:p>
+        </p:txBody>
       </p:sp>
       <p:sp>
         <p:nvSpPr>
@@ -6028,6 +5991,13 @@
           </a:solidFill>
           <a:ln/>
         </p:spPr>
+        <p:txBody>
+          <a:bodyPr/>
+          <a:lstStyle/>
+          <a:p>
+            <a:endParaRPr lang="en-GB"/>
+          </a:p>
+        </p:txBody>
       </p:sp>
       <p:sp>
         <p:nvSpPr>
@@ -6050,7 +6020,7 @@
           <a:bodyPr wrap="square" lIns="0" tIns="0" rIns="0" bIns="0" rtlCol="0" anchor="ctr"/>
           <a:lstStyle/>
           <a:p>
-            <a:pPr indent="0" marL="0">
+            <a:pPr marL="0" indent="0">
               <a:buNone/>
             </a:pPr>
             <a:r>
@@ -6089,7 +6059,7 @@
           <a:bodyPr wrap="square" lIns="0" tIns="0" rIns="0" bIns="0" rtlCol="0" anchor="ctr"/>
           <a:lstStyle/>
           <a:p>
-            <a:pPr indent="0" marL="0">
+            <a:pPr marL="0" indent="0">
               <a:buNone/>
             </a:pPr>
             <a:r>
@@ -6128,7 +6098,7 @@
           <a:bodyPr wrap="square" lIns="0" tIns="0" rIns="0" bIns="0" rtlCol="0" anchor="ctr"/>
           <a:lstStyle/>
           <a:p>
-            <a:pPr indent="0" marL="0">
+            <a:pPr marL="0" indent="0">
               <a:buNone/>
             </a:pPr>
             <a:r>
@@ -6170,6 +6140,13 @@
             <a:prstDash val="solid"/>
           </a:ln>
         </p:spPr>
+        <p:txBody>
+          <a:bodyPr/>
+          <a:lstStyle/>
+          <a:p>
+            <a:endParaRPr lang="en-GB"/>
+          </a:p>
+        </p:txBody>
       </p:sp>
       <p:sp>
         <p:nvSpPr>
@@ -6190,6 +6167,13 @@
           </a:solidFill>
           <a:ln/>
         </p:spPr>
+        <p:txBody>
+          <a:bodyPr/>
+          <a:lstStyle/>
+          <a:p>
+            <a:endParaRPr lang="en-GB"/>
+          </a:p>
+        </p:txBody>
       </p:sp>
       <p:sp>
         <p:nvSpPr>
@@ -6212,7 +6196,7 @@
           <a:bodyPr wrap="square" lIns="0" tIns="0" rIns="0" bIns="0" rtlCol="0" anchor="ctr"/>
           <a:lstStyle/>
           <a:p>
-            <a:pPr indent="0" marL="0">
+            <a:pPr marL="0" indent="0">
               <a:buNone/>
             </a:pPr>
             <a:r>
@@ -6251,7 +6235,7 @@
           <a:bodyPr wrap="square" lIns="0" tIns="0" rIns="0" bIns="0" rtlCol="0" anchor="ctr"/>
           <a:lstStyle/>
           <a:p>
-            <a:pPr indent="0" marL="0">
+            <a:pPr marL="0" indent="0">
               <a:buNone/>
             </a:pPr>
             <a:r>
@@ -6290,7 +6274,7 @@
           <a:bodyPr wrap="square" lIns="0" tIns="0" rIns="0" bIns="0" rtlCol="0" anchor="ctr"/>
           <a:lstStyle/>
           <a:p>
-            <a:pPr indent="0" marL="0">
+            <a:pPr marL="0" indent="0">
               <a:buNone/>
             </a:pPr>
             <a:r>
@@ -6332,6 +6316,13 @@
             <a:prstDash val="solid"/>
           </a:ln>
         </p:spPr>
+        <p:txBody>
+          <a:bodyPr/>
+          <a:lstStyle/>
+          <a:p>
+            <a:endParaRPr lang="en-GB"/>
+          </a:p>
+        </p:txBody>
       </p:sp>
       <p:sp>
         <p:nvSpPr>
@@ -6352,6 +6343,13 @@
           </a:solidFill>
           <a:ln/>
         </p:spPr>
+        <p:txBody>
+          <a:bodyPr/>
+          <a:lstStyle/>
+          <a:p>
+            <a:endParaRPr lang="en-GB"/>
+          </a:p>
+        </p:txBody>
       </p:sp>
       <p:sp>
         <p:nvSpPr>
@@ -6374,7 +6372,7 @@
           <a:bodyPr wrap="square" lIns="0" tIns="0" rIns="0" bIns="0" rtlCol="0" anchor="ctr"/>
           <a:lstStyle/>
           <a:p>
-            <a:pPr indent="0" marL="0">
+            <a:pPr marL="0" indent="0">
               <a:buNone/>
             </a:pPr>
             <a:r>
@@ -6413,7 +6411,7 @@
           <a:bodyPr wrap="square" lIns="0" tIns="0" rIns="0" bIns="0" rtlCol="0" anchor="ctr"/>
           <a:lstStyle/>
           <a:p>
-            <a:pPr indent="0" marL="0">
+            <a:pPr marL="0" indent="0">
               <a:buNone/>
             </a:pPr>
             <a:r>
@@ -6452,7 +6450,7 @@
           <a:bodyPr wrap="square" lIns="0" tIns="0" rIns="0" bIns="0" rtlCol="0" anchor="ctr"/>
           <a:lstStyle/>
           <a:p>
-            <a:pPr indent="0" marL="0">
+            <a:pPr marL="0" indent="0">
               <a:buNone/>
             </a:pPr>
             <a:r>
@@ -6494,6 +6492,13 @@
             <a:prstDash val="solid"/>
           </a:ln>
         </p:spPr>
+        <p:txBody>
+          <a:bodyPr/>
+          <a:lstStyle/>
+          <a:p>
+            <a:endParaRPr lang="en-GB"/>
+          </a:p>
+        </p:txBody>
       </p:sp>
       <p:sp>
         <p:nvSpPr>
@@ -6514,6 +6519,13 @@
           </a:solidFill>
           <a:ln/>
         </p:spPr>
+        <p:txBody>
+          <a:bodyPr/>
+          <a:lstStyle/>
+          <a:p>
+            <a:endParaRPr lang="en-GB"/>
+          </a:p>
+        </p:txBody>
       </p:sp>
       <p:sp>
         <p:nvSpPr>
@@ -6536,7 +6548,7 @@
           <a:bodyPr wrap="square" lIns="0" tIns="0" rIns="0" bIns="0" rtlCol="0" anchor="ctr"/>
           <a:lstStyle/>
           <a:p>
-            <a:pPr indent="0" marL="0">
+            <a:pPr marL="0" indent="0">
               <a:buNone/>
             </a:pPr>
             <a:r>
@@ -6575,7 +6587,7 @@
           <a:bodyPr wrap="square" lIns="0" tIns="0" rIns="0" bIns="0" rtlCol="0" anchor="ctr"/>
           <a:lstStyle/>
           <a:p>
-            <a:pPr indent="0" marL="0">
+            <a:pPr marL="0" indent="0">
               <a:buNone/>
             </a:pPr>
             <a:r>
@@ -6614,7 +6626,7 @@
           <a:bodyPr wrap="square" lIns="0" tIns="0" rIns="0" bIns="0" rtlCol="0" anchor="ctr"/>
           <a:lstStyle/>
           <a:p>
-            <a:pPr indent="0" marL="0">
+            <a:pPr marL="0" indent="0">
               <a:buNone/>
             </a:pPr>
             <a:r>
@@ -6656,6 +6668,13 @@
             <a:prstDash val="solid"/>
           </a:ln>
         </p:spPr>
+        <p:txBody>
+          <a:bodyPr/>
+          <a:lstStyle/>
+          <a:p>
+            <a:endParaRPr lang="en-GB"/>
+          </a:p>
+        </p:txBody>
       </p:sp>
       <p:sp>
         <p:nvSpPr>
@@ -6678,7 +6697,7 @@
           <a:bodyPr wrap="square" lIns="0" tIns="0" rIns="0" bIns="0" rtlCol="0" anchor="ctr"/>
           <a:lstStyle/>
           <a:p>
-            <a:pPr indent="0" marL="0">
+            <a:pPr marL="0" indent="0">
               <a:buNone/>
             </a:pPr>
             <a:r>
@@ -6698,7 +6717,7 @@
       </p:sp>
       <p:graphicFrame>
         <p:nvGraphicFramePr>
-          <p:cNvPr id="8" name="Table 0"/>
+          <p:cNvPr id="28" name="Table 0"/>
           <p:cNvGraphicFramePr>
             <a:graphicFrameLocks noGrp="1"/>
           </p:cNvGraphicFramePr>
@@ -6719,9 +6738,27 @@
             <a:tbl>
               <a:tblPr/>
               <a:tblGrid>
-                <a:gridCol w="1737360"/>
-                <a:gridCol w="1828800"/>
-                <a:gridCol w="1828800"/>
+                <a:gridCol w="1737360">
+                  <a:extLst>
+                    <a:ext uri="{9D8B030D-6E8A-4147-A177-3AD203B41FA5}">
+                      <a16:colId xmlns:a16="http://schemas.microsoft.com/office/drawing/2014/main" val="20000"/>
+                    </a:ext>
+                  </a:extLst>
+                </a:gridCol>
+                <a:gridCol w="1828800">
+                  <a:extLst>
+                    <a:ext uri="{9D8B030D-6E8A-4147-A177-3AD203B41FA5}">
+                      <a16:colId xmlns:a16="http://schemas.microsoft.com/office/drawing/2014/main" val="20001"/>
+                    </a:ext>
+                  </a:extLst>
+                </a:gridCol>
+                <a:gridCol w="1828800">
+                  <a:extLst>
+                    <a:ext uri="{9D8B030D-6E8A-4147-A177-3AD203B41FA5}">
+                      <a16:colId xmlns:a16="http://schemas.microsoft.com/office/drawing/2014/main" val="20002"/>
+                    </a:ext>
+                  </a:extLst>
+                </a:gridCol>
               </a:tblGrid>
               <a:tr h="396240">
                 <a:tc>
@@ -6729,7 +6766,7 @@
                     <a:bodyPr/>
                     <a:lstStyle/>
                     <a:p>
-                      <a:pPr indent="0" marL="0">
+                      <a:pPr marL="0" indent="0">
                         <a:buNone/>
                       </a:pPr>
                       <a:endParaRPr lang="en-US" sz="1200" dirty="0">
@@ -6739,7 +6776,7 @@
                       </a:endParaRPr>
                     </a:p>
                   </a:txBody>
-                  <a:tcPr marL="91440" marR="91440" marT="45720" marB="45720" anchor="ctr">
+                  <a:tcPr anchor="ctr">
                     <a:lnL w="6350" cap="flat" cmpd="sng" algn="ctr">
                       <a:solidFill>
                         <a:srgbClr val="E0E5EB"/>
@@ -6786,7 +6823,7 @@
                     <a:bodyPr/>
                     <a:lstStyle/>
                     <a:p>
-                      <a:pPr indent="0" marL="0">
+                      <a:pPr marL="0" indent="0">
                         <a:buNone/>
                       </a:pPr>
                       <a:r>
@@ -6807,7 +6844,7 @@
                       </a:endParaRPr>
                     </a:p>
                   </a:txBody>
-                  <a:tcPr marL="91440" marR="91440" marT="45720" marB="45720" anchor="ctr">
+                  <a:tcPr anchor="ctr">
                     <a:lnL w="6350" cap="flat" cmpd="sng" algn="ctr">
                       <a:solidFill>
                         <a:srgbClr val="E0E5EB"/>
@@ -6854,7 +6891,7 @@
                     <a:bodyPr/>
                     <a:lstStyle/>
                     <a:p>
-                      <a:pPr indent="0" marL="0">
+                      <a:pPr marL="0" indent="0">
                         <a:buNone/>
                       </a:pPr>
                       <a:r>
@@ -6875,7 +6912,7 @@
                       </a:endParaRPr>
                     </a:p>
                   </a:txBody>
-                  <a:tcPr marL="91440" marR="91440" marT="45720" marB="45720" anchor="ctr">
+                  <a:tcPr anchor="ctr">
                     <a:lnL w="6350" cap="flat" cmpd="sng" algn="ctr">
                       <a:solidFill>
                         <a:srgbClr val="E0E5EB"/>
@@ -6917,6 +6954,11 @@
                     </a:solidFill>
                   </a:tcPr>
                 </a:tc>
+                <a:extLst>
+                  <a:ext uri="{0D108BD9-81ED-4DB2-BD59-A6C34878D82A}">
+                    <a16:rowId xmlns:a16="http://schemas.microsoft.com/office/drawing/2014/main" val="10000"/>
+                  </a:ext>
+                </a:extLst>
               </a:tr>
               <a:tr h="396240">
                 <a:tc>
@@ -6924,7 +6966,7 @@
                     <a:bodyPr/>
                     <a:lstStyle/>
                     <a:p>
-                      <a:pPr indent="0" marL="0">
+                      <a:pPr marL="0" indent="0">
                         <a:buNone/>
                       </a:pPr>
                       <a:r>
@@ -6945,7 +6987,7 @@
                       </a:endParaRPr>
                     </a:p>
                   </a:txBody>
-                  <a:tcPr marL="91440" marR="91440" marT="45720" marB="45720" anchor="ctr">
+                  <a:tcPr anchor="ctr">
                     <a:lnL w="6350" cap="flat" cmpd="sng" algn="ctr">
                       <a:solidFill>
                         <a:srgbClr val="E0E5EB"/>
@@ -6992,7 +7034,7 @@
                     <a:bodyPr/>
                     <a:lstStyle/>
                     <a:p>
-                      <a:pPr algn="ctr" indent="0" marL="0">
+                      <a:pPr marL="0" indent="0" algn="ctr">
                         <a:buNone/>
                       </a:pPr>
                       <a:r>
@@ -7013,7 +7055,7 @@
                       </a:endParaRPr>
                     </a:p>
                   </a:txBody>
-                  <a:tcPr marL="91440" marR="91440" marT="45720" marB="45720" anchor="ctr">
+                  <a:tcPr anchor="ctr">
                     <a:lnL w="6350" cap="flat" cmpd="sng" algn="ctr">
                       <a:solidFill>
                         <a:srgbClr val="E0E5EB"/>
@@ -7057,7 +7099,7 @@
                     <a:bodyPr/>
                     <a:lstStyle/>
                     <a:p>
-                      <a:pPr algn="ctr" indent="0" marL="0">
+                      <a:pPr marL="0" indent="0" algn="ctr">
                         <a:buNone/>
                       </a:pPr>
                       <a:r>
@@ -7078,7 +7120,7 @@
                       </a:endParaRPr>
                     </a:p>
                   </a:txBody>
-                  <a:tcPr marL="91440" marR="91440" marT="45720" marB="45720" anchor="ctr">
+                  <a:tcPr anchor="ctr">
                     <a:lnL w="6350" cap="flat" cmpd="sng" algn="ctr">
                       <a:solidFill>
                         <a:srgbClr val="E0E5EB"/>
@@ -7117,6 +7159,11 @@
                     </a:lnB>
                   </a:tcPr>
                 </a:tc>
+                <a:extLst>
+                  <a:ext uri="{0D108BD9-81ED-4DB2-BD59-A6C34878D82A}">
+                    <a16:rowId xmlns:a16="http://schemas.microsoft.com/office/drawing/2014/main" val="10001"/>
+                  </a:ext>
+                </a:extLst>
               </a:tr>
               <a:tr h="396240">
                 <a:tc>
@@ -7124,7 +7171,7 @@
                     <a:bodyPr/>
                     <a:lstStyle/>
                     <a:p>
-                      <a:pPr indent="0" marL="0">
+                      <a:pPr marL="0" indent="0">
                         <a:buNone/>
                       </a:pPr>
                       <a:r>
@@ -7145,7 +7192,7 @@
                       </a:endParaRPr>
                     </a:p>
                   </a:txBody>
-                  <a:tcPr marL="91440" marR="91440" marT="45720" marB="45720" anchor="ctr">
+                  <a:tcPr anchor="ctr">
                     <a:lnL w="6350" cap="flat" cmpd="sng" algn="ctr">
                       <a:solidFill>
                         <a:srgbClr val="E0E5EB"/>
@@ -7192,7 +7239,7 @@
                     <a:bodyPr/>
                     <a:lstStyle/>
                     <a:p>
-                      <a:pPr algn="ctr" indent="0" marL="0">
+                      <a:pPr marL="0" indent="0" algn="ctr">
                         <a:buNone/>
                       </a:pPr>
                       <a:r>
@@ -7213,7 +7260,7 @@
                       </a:endParaRPr>
                     </a:p>
                   </a:txBody>
-                  <a:tcPr marL="91440" marR="91440" marT="45720" marB="45720" anchor="ctr">
+                  <a:tcPr anchor="ctr">
                     <a:lnL w="6350" cap="flat" cmpd="sng" algn="ctr">
                       <a:solidFill>
                         <a:srgbClr val="E0E5EB"/>
@@ -7257,7 +7304,7 @@
                     <a:bodyPr/>
                     <a:lstStyle/>
                     <a:p>
-                      <a:pPr algn="ctr" indent="0" marL="0">
+                      <a:pPr marL="0" indent="0" algn="ctr">
                         <a:buNone/>
                       </a:pPr>
                       <a:r>
@@ -7278,7 +7325,7 @@
                       </a:endParaRPr>
                     </a:p>
                   </a:txBody>
-                  <a:tcPr marL="91440" marR="91440" marT="45720" marB="45720" anchor="ctr">
+                  <a:tcPr anchor="ctr">
                     <a:lnL w="6350" cap="flat" cmpd="sng" algn="ctr">
                       <a:solidFill>
                         <a:srgbClr val="E0E5EB"/>
@@ -7317,6 +7364,11 @@
                     </a:lnB>
                   </a:tcPr>
                 </a:tc>
+                <a:extLst>
+                  <a:ext uri="{0D108BD9-81ED-4DB2-BD59-A6C34878D82A}">
+                    <a16:rowId xmlns:a16="http://schemas.microsoft.com/office/drawing/2014/main" val="10002"/>
+                  </a:ext>
+                </a:extLst>
               </a:tr>
             </a:tbl>
           </a:graphicData>
@@ -7338,6 +7390,7 @@
         <a:solidFill>
           <a:srgbClr val="F4F7FA"/>
         </a:solidFill>
+        <a:effectLst/>
       </p:bgPr>
     </p:bg>
     <p:spTree>
@@ -7375,7 +7428,7 @@
           <a:bodyPr wrap="square" lIns="0" tIns="0" rIns="0" bIns="0" rtlCol="0" anchor="ctr"/>
           <a:lstStyle/>
           <a:p>
-            <a:pPr indent="0" marL="0">
+            <a:pPr marL="0" indent="0">
               <a:buNone/>
             </a:pPr>
             <a:r>
@@ -7414,7 +7467,7 @@
           <a:bodyPr wrap="square" lIns="0" tIns="0" rIns="0" bIns="0" rtlCol="0" anchor="ctr"/>
           <a:lstStyle/>
           <a:p>
-            <a:pPr indent="0" marL="0">
+            <a:pPr marL="0" indent="0">
               <a:buNone/>
             </a:pPr>
             <a:r>
@@ -7454,17 +7507,24 @@
             <a:prstDash val="solid"/>
           </a:ln>
         </p:spPr>
+        <p:txBody>
+          <a:bodyPr/>
+          <a:lstStyle/>
+          <a:p>
+            <a:endParaRPr lang="en-GB"/>
+          </a:p>
+        </p:txBody>
       </p:sp>
       <p:pic>
         <p:nvPicPr>
-          <p:cNvPr id="5" name="Image 0" descr="/home/claude/nhse_test/outputs/4_feature_importance.png">    </p:cNvPr>
+          <p:cNvPr id="5" name="Image 0" descr="/home/claude/nhse_test/outputs/4_feature_importance.png"/>
           <p:cNvPicPr>
             <a:picLocks noChangeAspect="1"/>
           </p:cNvPicPr>
           <p:nvPr/>
         </p:nvPicPr>
         <p:blipFill>
-          <a:blip r:embed="rId1"/>
+          <a:blip r:embed="rId3"/>
           <a:stretch>
             <a:fillRect/>
           </a:stretch>
@@ -7503,6 +7563,13 @@
             <a:prstDash val="solid"/>
           </a:ln>
         </p:spPr>
+        <p:txBody>
+          <a:bodyPr/>
+          <a:lstStyle/>
+          <a:p>
+            <a:endParaRPr lang="en-GB"/>
+          </a:p>
+        </p:txBody>
       </p:sp>
       <p:sp>
         <p:nvSpPr>
@@ -7525,7 +7592,7 @@
           <a:bodyPr wrap="square" lIns="0" tIns="0" rIns="0" bIns="0" rtlCol="0" anchor="ctr"/>
           <a:lstStyle/>
           <a:p>
-            <a:pPr indent="0" marL="0">
+            <a:pPr marL="0" indent="0">
               <a:buNone/>
             </a:pPr>
             <a:r>
@@ -7564,7 +7631,7 @@
           <a:bodyPr wrap="square" lIns="0" tIns="0" rIns="0" bIns="0" rtlCol="0" anchor="ctr"/>
           <a:lstStyle/>
           <a:p>
-            <a:pPr indent="0" marL="0">
+            <a:pPr marL="0" indent="0">
               <a:spcAft>
                 <a:spcPts val="400"/>
               </a:spcAft>
@@ -7584,7 +7651,7 @@
             <a:endParaRPr lang="en-US" sz="1200" dirty="0"/>
           </a:p>
           <a:p>
-            <a:pPr indent="0" marL="0">
+            <a:pPr marL="0" indent="0">
               <a:buNone/>
             </a:pPr>
             <a:r>
@@ -7601,7 +7668,7 @@
             <a:endParaRPr lang="en-US" sz="1200" dirty="0"/>
           </a:p>
           <a:p>
-            <a:pPr indent="0" marL="0">
+            <a:pPr marL="0" indent="0">
               <a:buNone/>
             </a:pPr>
             <a:r>
@@ -7618,7 +7685,7 @@
             <a:endParaRPr lang="en-US" sz="1200" dirty="0"/>
           </a:p>
           <a:p>
-            <a:pPr indent="0" marL="0">
+            <a:pPr marL="0" indent="0">
               <a:buNone/>
             </a:pPr>
             <a:r>
@@ -7635,7 +7702,7 @@
             <a:endParaRPr lang="en-US" sz="1200" dirty="0"/>
           </a:p>
           <a:p>
-            <a:pPr indent="0" marL="0">
+            <a:pPr marL="0" indent="0">
               <a:spcAft>
                 <a:spcPts val="1000"/>
               </a:spcAft>
@@ -7655,7 +7722,7 @@
             <a:endParaRPr lang="en-US" sz="1200" dirty="0"/>
           </a:p>
           <a:p>
-            <a:pPr indent="0" marL="0">
+            <a:pPr marL="0" indent="0">
               <a:spcAft>
                 <a:spcPts val="400"/>
               </a:spcAft>
@@ -7675,7 +7742,7 @@
             <a:endParaRPr lang="en-US" sz="1200" dirty="0"/>
           </a:p>
           <a:p>
-            <a:pPr indent="0" marL="0">
+            <a:pPr marL="0" indent="0">
               <a:spcAft>
                 <a:spcPts val="800"/>
               </a:spcAft>
@@ -7695,7 +7762,7 @@
             <a:endParaRPr lang="en-US" sz="1200" dirty="0"/>
           </a:p>
           <a:p>
-            <a:pPr indent="0" marL="0">
+            <a:pPr marL="0" indent="0">
               <a:spcAft>
                 <a:spcPts val="400"/>
               </a:spcAft>
@@ -7715,7 +7782,7 @@
             <a:endParaRPr lang="en-US" sz="1200" dirty="0"/>
           </a:p>
           <a:p>
-            <a:pPr indent="0" marL="0">
+            <a:pPr marL="0" indent="0">
               <a:buNone/>
             </a:pPr>
             <a:r>
@@ -7749,6 +7816,7 @@
         <a:solidFill>
           <a:srgbClr val="F4F7FA"/>
         </a:solidFill>
+        <a:effectLst/>
       </p:bgPr>
     </p:bg>
     <p:spTree>
@@ -7786,7 +7854,7 @@
           <a:bodyPr wrap="square" lIns="0" tIns="0" rIns="0" bIns="0" rtlCol="0" anchor="ctr"/>
           <a:lstStyle/>
           <a:p>
-            <a:pPr indent="0" marL="0">
+            <a:pPr marL="0" indent="0">
               <a:buNone/>
             </a:pPr>
             <a:r>
@@ -7825,7 +7893,7 @@
           <a:bodyPr wrap="square" lIns="0" tIns="0" rIns="0" bIns="0" rtlCol="0" anchor="ctr"/>
           <a:lstStyle/>
           <a:p>
-            <a:pPr indent="0" marL="0">
+            <a:pPr marL="0" indent="0">
               <a:buNone/>
             </a:pPr>
             <a:r>
@@ -7865,6 +7933,13 @@
             <a:prstDash val="solid"/>
           </a:ln>
         </p:spPr>
+        <p:txBody>
+          <a:bodyPr/>
+          <a:lstStyle/>
+          <a:p>
+            <a:endParaRPr lang="en-GB"/>
+          </a:p>
+        </p:txBody>
       </p:sp>
       <p:sp>
         <p:nvSpPr>
@@ -7890,13 +7965,20 @@
             <a:prstDash val="solid"/>
           </a:ln>
           <a:effectLst>
-            <a:outerShdw sx="100000" sy="100000" kx="0" ky="0" algn="bl" rotWithShape="0" blurRad="76200" dist="12700" dir="8100000">
+            <a:outerShdw blurRad="76200" dist="12700" dir="8100000" algn="bl" rotWithShape="0">
               <a:srgbClr val="000000">
                 <a:alpha val="8000"/>
               </a:srgbClr>
             </a:outerShdw>
           </a:effectLst>
         </p:spPr>
+        <p:txBody>
+          <a:bodyPr/>
+          <a:lstStyle/>
+          <a:p>
+            <a:endParaRPr lang="en-GB"/>
+          </a:p>
+        </p:txBody>
       </p:sp>
       <p:sp>
         <p:nvSpPr>
@@ -7917,6 +7999,13 @@
           </a:solidFill>
           <a:ln/>
         </p:spPr>
+        <p:txBody>
+          <a:bodyPr/>
+          <a:lstStyle/>
+          <a:p>
+            <a:endParaRPr lang="en-GB"/>
+          </a:p>
+        </p:txBody>
       </p:sp>
       <p:sp>
         <p:nvSpPr>
@@ -7939,7 +8028,7 @@
           <a:bodyPr wrap="square" lIns="0" tIns="0" rIns="0" bIns="0" rtlCol="0" anchor="ctr"/>
           <a:lstStyle/>
           <a:p>
-            <a:pPr indent="0" marL="0">
+            <a:pPr marL="0" indent="0">
               <a:buNone/>
             </a:pPr>
             <a:r>
@@ -8087,13 +8176,20 @@
             <a:prstDash val="solid"/>
           </a:ln>
           <a:effectLst>
-            <a:outerShdw sx="100000" sy="100000" kx="0" ky="0" algn="bl" rotWithShape="0" blurRad="76200" dist="12700" dir="8100000">
+            <a:outerShdw blurRad="76200" dist="12700" dir="8100000" algn="bl" rotWithShape="0">
               <a:srgbClr val="000000">
                 <a:alpha val="8000"/>
               </a:srgbClr>
             </a:outerShdw>
           </a:effectLst>
         </p:spPr>
+        <p:txBody>
+          <a:bodyPr/>
+          <a:lstStyle/>
+          <a:p>
+            <a:endParaRPr lang="en-GB"/>
+          </a:p>
+        </p:txBody>
       </p:sp>
       <p:sp>
         <p:nvSpPr>
@@ -8114,6 +8210,13 @@
           </a:solidFill>
           <a:ln/>
         </p:spPr>
+        <p:txBody>
+          <a:bodyPr/>
+          <a:lstStyle/>
+          <a:p>
+            <a:endParaRPr lang="en-GB"/>
+          </a:p>
+        </p:txBody>
       </p:sp>
       <p:sp>
         <p:nvSpPr>
@@ -8136,7 +8239,7 @@
           <a:bodyPr wrap="square" lIns="0" tIns="0" rIns="0" bIns="0" rtlCol="0" anchor="ctr"/>
           <a:lstStyle/>
           <a:p>
-            <a:pPr indent="0" marL="0">
+            <a:pPr marL="0" indent="0">
               <a:buNone/>
             </a:pPr>
             <a:r>
@@ -8284,13 +8387,20 @@
             <a:prstDash val="solid"/>
           </a:ln>
           <a:effectLst>
-            <a:outerShdw sx="100000" sy="100000" kx="0" ky="0" algn="bl" rotWithShape="0" blurRad="76200" dist="12700" dir="8100000">
+            <a:outerShdw blurRad="76200" dist="12700" dir="8100000" algn="bl" rotWithShape="0">
               <a:srgbClr val="000000">
                 <a:alpha val="8000"/>
               </a:srgbClr>
             </a:outerShdw>
           </a:effectLst>
         </p:spPr>
+        <p:txBody>
+          <a:bodyPr/>
+          <a:lstStyle/>
+          <a:p>
+            <a:endParaRPr lang="en-GB"/>
+          </a:p>
+        </p:txBody>
       </p:sp>
       <p:sp>
         <p:nvSpPr>
@@ -8311,6 +8421,13 @@
           </a:solidFill>
           <a:ln/>
         </p:spPr>
+        <p:txBody>
+          <a:bodyPr/>
+          <a:lstStyle/>
+          <a:p>
+            <a:endParaRPr lang="en-GB"/>
+          </a:p>
+        </p:txBody>
       </p:sp>
       <p:sp>
         <p:nvSpPr>
@@ -8333,7 +8450,7 @@
           <a:bodyPr wrap="square" lIns="0" tIns="0" rIns="0" bIns="0" rtlCol="0" anchor="ctr"/>
           <a:lstStyle/>
           <a:p>
-            <a:pPr indent="0" marL="0">
+            <a:pPr marL="0" indent="0">
               <a:buNone/>
             </a:pPr>
             <a:r>
@@ -8758,4 +8875,325 @@
     </a:ext>
   </a:extLst>
 </a:theme>
+</file>
+
+<file path=ppt/theme/theme2.xml><?xml version="1.0" encoding="utf-8"?>
+<a:theme xmlns:a="http://schemas.openxmlformats.org/drawingml/2006/main" name="Office Theme">
+  <a:themeElements>
+    <a:clrScheme name="Office">
+      <a:dk1>
+        <a:sysClr val="windowText" lastClr="000000"/>
+      </a:dk1>
+      <a:lt1>
+        <a:sysClr val="window" lastClr="FFFFFF"/>
+      </a:lt1>
+      <a:dk2>
+        <a:srgbClr val="0E2841"/>
+      </a:dk2>
+      <a:lt2>
+        <a:srgbClr val="E8E8E8"/>
+      </a:lt2>
+      <a:accent1>
+        <a:srgbClr val="156082"/>
+      </a:accent1>
+      <a:accent2>
+        <a:srgbClr val="E97132"/>
+      </a:accent2>
+      <a:accent3>
+        <a:srgbClr val="196B24"/>
+      </a:accent3>
+      <a:accent4>
+        <a:srgbClr val="0F9ED5"/>
+      </a:accent4>
+      <a:accent5>
+        <a:srgbClr val="A02B93"/>
+      </a:accent5>
+      <a:accent6>
+        <a:srgbClr val="4EA72E"/>
+      </a:accent6>
+      <a:hlink>
+        <a:srgbClr val="467886"/>
+      </a:hlink>
+      <a:folHlink>
+        <a:srgbClr val="96607D"/>
+      </a:folHlink>
+    </a:clrScheme>
+    <a:fontScheme name="Office">
+      <a:majorFont>
+        <a:latin typeface="Aptos Display" panose="02110004020202020204"/>
+        <a:ea typeface=""/>
+        <a:cs typeface=""/>
+        <a:font script="Jpan" typeface="游ゴシック Light"/>
+        <a:font script="Hang" typeface="맑은 고딕"/>
+        <a:font script="Hans" typeface="等线 Light"/>
+        <a:font script="Hant" typeface="新細明體"/>
+        <a:font script="Arab" typeface="Times New Roman"/>
+        <a:font script="Hebr" typeface="Times New Roman"/>
+        <a:font script="Thai" typeface="Angsana New"/>
+        <a:font script="Ethi" typeface="Nyala"/>
+        <a:font script="Beng" typeface="Vrinda"/>
+        <a:font script="Gujr" typeface="Shruti"/>
+        <a:font script="Khmr" typeface="MoolBoran"/>
+        <a:font script="Knda" typeface="Tunga"/>
+        <a:font script="Guru" typeface="Raavi"/>
+        <a:font script="Cans" typeface="Euphemia"/>
+        <a:font script="Cher" typeface="Plantagenet Cherokee"/>
+        <a:font script="Yiii" typeface="Microsoft Yi Baiti"/>
+        <a:font script="Tibt" typeface="Microsoft Himalaya"/>
+        <a:font script="Thaa" typeface="MV Boli"/>
+        <a:font script="Deva" typeface="Mangal"/>
+        <a:font script="Telu" typeface="Gautami"/>
+        <a:font script="Taml" typeface="Latha"/>
+        <a:font script="Syrc" typeface="Estrangelo Edessa"/>
+        <a:font script="Orya" typeface="Kalinga"/>
+        <a:font script="Mlym" typeface="Kartika"/>
+        <a:font script="Laoo" typeface="DokChampa"/>
+        <a:font script="Sinh" typeface="Iskoola Pota"/>
+        <a:font script="Mong" typeface="Mongolian Baiti"/>
+        <a:font script="Viet" typeface="Times New Roman"/>
+        <a:font script="Uigh" typeface="Microsoft Uighur"/>
+        <a:font script="Geor" typeface="Sylfaen"/>
+        <a:font script="Armn" typeface="Arial"/>
+        <a:font script="Bugi" typeface="Leelawadee UI"/>
+        <a:font script="Bopo" typeface="Microsoft JhengHei"/>
+        <a:font script="Java" typeface="Javanese Text"/>
+        <a:font script="Lisu" typeface="Segoe UI"/>
+        <a:font script="Mymr" typeface="Myanmar Text"/>
+        <a:font script="Nkoo" typeface="Ebrima"/>
+        <a:font script="Olck" typeface="Nirmala UI"/>
+        <a:font script="Osma" typeface="Ebrima"/>
+        <a:font script="Phag" typeface="Phagspa"/>
+        <a:font script="Syrn" typeface="Estrangelo Edessa"/>
+        <a:font script="Syrj" typeface="Estrangelo Edessa"/>
+        <a:font script="Syre" typeface="Estrangelo Edessa"/>
+        <a:font script="Sora" typeface="Nirmala UI"/>
+        <a:font script="Tale" typeface="Microsoft Tai Le"/>
+        <a:font script="Talu" typeface="Microsoft New Tai Lue"/>
+        <a:font script="Tfng" typeface="Ebrima"/>
+      </a:majorFont>
+      <a:minorFont>
+        <a:latin typeface="Aptos" panose="02110004020202020204"/>
+        <a:ea typeface=""/>
+        <a:cs typeface=""/>
+        <a:font script="Jpan" typeface="游ゴシック"/>
+        <a:font script="Hang" typeface="맑은 고딕"/>
+        <a:font script="Hans" typeface="等线"/>
+        <a:font script="Hant" typeface="新細明體"/>
+        <a:font script="Arab" typeface="Arial"/>
+        <a:font script="Hebr" typeface="Arial"/>
+        <a:font script="Thai" typeface="Cordia New"/>
+        <a:font script="Ethi" typeface="Nyala"/>
+        <a:font script="Beng" typeface="Vrinda"/>
+        <a:font script="Gujr" typeface="Shruti"/>
+        <a:font script="Khmr" typeface="DaunPenh"/>
+        <a:font script="Knda" typeface="Tunga"/>
+        <a:font script="Guru" typeface="Raavi"/>
+        <a:font script="Cans" typeface="Euphemia"/>
+        <a:font script="Cher" typeface="Plantagenet Cherokee"/>
+        <a:font script="Yiii" typeface="Microsoft Yi Baiti"/>
+        <a:font script="Tibt" typeface="Microsoft Himalaya"/>
+        <a:font script="Thaa" typeface="MV Boli"/>
+        <a:font script="Deva" typeface="Mangal"/>
+        <a:font script="Telu" typeface="Gautami"/>
+        <a:font script="Taml" typeface="Latha"/>
+        <a:font script="Syrc" typeface="Estrangelo Edessa"/>
+        <a:font script="Orya" typeface="Kalinga"/>
+        <a:font script="Mlym" typeface="Kartika"/>
+        <a:font script="Laoo" typeface="DokChampa"/>
+        <a:font script="Sinh" typeface="Iskoola Pota"/>
+        <a:font script="Mong" typeface="Mongolian Baiti"/>
+        <a:font script="Viet" typeface="Arial"/>
+        <a:font script="Uigh" typeface="Microsoft Uighur"/>
+        <a:font script="Geor" typeface="Sylfaen"/>
+        <a:font script="Armn" typeface="Arial"/>
+        <a:font script="Bugi" typeface="Leelawadee UI"/>
+        <a:font script="Bopo" typeface="Microsoft JhengHei"/>
+        <a:font script="Java" typeface="Javanese Text"/>
+        <a:font script="Lisu" typeface="Segoe UI"/>
+        <a:font script="Mymr" typeface="Myanmar Text"/>
+        <a:font script="Nkoo" typeface="Ebrima"/>
+        <a:font script="Olck" typeface="Nirmala UI"/>
+        <a:font script="Osma" typeface="Ebrima"/>
+        <a:font script="Phag" typeface="Phagspa"/>
+        <a:font script="Syrn" typeface="Estrangelo Edessa"/>
+        <a:font script="Syrj" typeface="Estrangelo Edessa"/>
+        <a:font script="Syre" typeface="Estrangelo Edessa"/>
+        <a:font script="Sora" typeface="Nirmala UI"/>
+        <a:font script="Tale" typeface="Microsoft Tai Le"/>
+        <a:font script="Talu" typeface="Microsoft New Tai Lue"/>
+        <a:font script="Tfng" typeface="Ebrima"/>
+      </a:minorFont>
+    </a:fontScheme>
+    <a:fmtScheme name="Office">
+      <a:fillStyleLst>
+        <a:solidFill>
+          <a:schemeClr val="phClr"/>
+        </a:solidFill>
+        <a:gradFill rotWithShape="1">
+          <a:gsLst>
+            <a:gs pos="0">
+              <a:schemeClr val="phClr">
+                <a:lumMod val="110000"/>
+                <a:satMod val="105000"/>
+                <a:tint val="67000"/>
+              </a:schemeClr>
+            </a:gs>
+            <a:gs pos="50000">
+              <a:schemeClr val="phClr">
+                <a:lumMod val="105000"/>
+                <a:satMod val="103000"/>
+                <a:tint val="73000"/>
+              </a:schemeClr>
+            </a:gs>
+            <a:gs pos="100000">
+              <a:schemeClr val="phClr">
+                <a:lumMod val="105000"/>
+                <a:satMod val="109000"/>
+                <a:tint val="81000"/>
+              </a:schemeClr>
+            </a:gs>
+          </a:gsLst>
+          <a:lin ang="5400000" scaled="0"/>
+        </a:gradFill>
+        <a:gradFill rotWithShape="1">
+          <a:gsLst>
+            <a:gs pos="0">
+              <a:schemeClr val="phClr">
+                <a:satMod val="103000"/>
+                <a:lumMod val="102000"/>
+                <a:tint val="94000"/>
+              </a:schemeClr>
+            </a:gs>
+            <a:gs pos="50000">
+              <a:schemeClr val="phClr">
+                <a:satMod val="110000"/>
+                <a:lumMod val="100000"/>
+                <a:shade val="100000"/>
+              </a:schemeClr>
+            </a:gs>
+            <a:gs pos="100000">
+              <a:schemeClr val="phClr">
+                <a:lumMod val="99000"/>
+                <a:satMod val="120000"/>
+                <a:shade val="78000"/>
+              </a:schemeClr>
+            </a:gs>
+          </a:gsLst>
+          <a:lin ang="5400000" scaled="0"/>
+        </a:gradFill>
+      </a:fillStyleLst>
+      <a:lnStyleLst>
+        <a:ln w="12700" cap="flat" cmpd="sng" algn="ctr">
+          <a:solidFill>
+            <a:schemeClr val="phClr"/>
+          </a:solidFill>
+          <a:prstDash val="solid"/>
+          <a:miter lim="800000"/>
+        </a:ln>
+        <a:ln w="19050" cap="flat" cmpd="sng" algn="ctr">
+          <a:solidFill>
+            <a:schemeClr val="phClr"/>
+          </a:solidFill>
+          <a:prstDash val="solid"/>
+          <a:miter lim="800000"/>
+        </a:ln>
+        <a:ln w="25400" cap="flat" cmpd="sng" algn="ctr">
+          <a:solidFill>
+            <a:schemeClr val="phClr"/>
+          </a:solidFill>
+          <a:prstDash val="solid"/>
+          <a:miter lim="800000"/>
+        </a:ln>
+      </a:lnStyleLst>
+      <a:effectStyleLst>
+        <a:effectStyle>
+          <a:effectLst/>
+        </a:effectStyle>
+        <a:effectStyle>
+          <a:effectLst/>
+        </a:effectStyle>
+        <a:effectStyle>
+          <a:effectLst>
+            <a:outerShdw blurRad="57150" dist="19050" dir="5400000" algn="ctr" rotWithShape="0">
+              <a:srgbClr val="000000">
+                <a:alpha val="63000"/>
+              </a:srgbClr>
+            </a:outerShdw>
+          </a:effectLst>
+        </a:effectStyle>
+      </a:effectStyleLst>
+      <a:bgFillStyleLst>
+        <a:solidFill>
+          <a:schemeClr val="phClr"/>
+        </a:solidFill>
+        <a:solidFill>
+          <a:schemeClr val="phClr">
+            <a:tint val="95000"/>
+            <a:satMod val="170000"/>
+          </a:schemeClr>
+        </a:solidFill>
+        <a:gradFill rotWithShape="1">
+          <a:gsLst>
+            <a:gs pos="0">
+              <a:schemeClr val="phClr">
+                <a:tint val="93000"/>
+                <a:satMod val="150000"/>
+                <a:shade val="98000"/>
+                <a:lumMod val="102000"/>
+              </a:schemeClr>
+            </a:gs>
+            <a:gs pos="50000">
+              <a:schemeClr val="phClr">
+                <a:tint val="98000"/>
+                <a:satMod val="130000"/>
+                <a:shade val="90000"/>
+                <a:lumMod val="103000"/>
+              </a:schemeClr>
+            </a:gs>
+            <a:gs pos="100000">
+              <a:schemeClr val="phClr">
+                <a:shade val="63000"/>
+                <a:satMod val="120000"/>
+              </a:schemeClr>
+            </a:gs>
+          </a:gsLst>
+          <a:lin ang="5400000" scaled="0"/>
+        </a:gradFill>
+      </a:bgFillStyleLst>
+    </a:fmtScheme>
+  </a:themeElements>
+  <a:objectDefaults>
+    <a:lnDef>
+      <a:spPr/>
+      <a:bodyPr/>
+      <a:lstStyle/>
+      <a:style>
+        <a:lnRef idx="2">
+          <a:schemeClr val="accent1"/>
+        </a:lnRef>
+        <a:fillRef idx="0">
+          <a:schemeClr val="accent1"/>
+        </a:fillRef>
+        <a:effectRef idx="1">
+          <a:schemeClr val="accent1"/>
+        </a:effectRef>
+        <a:fontRef idx="minor">
+          <a:schemeClr val="tx1"/>
+        </a:fontRef>
+      </a:style>
+    </a:lnDef>
+  </a:objectDefaults>
+  <a:extraClrSchemeLst/>
+  <a:extLst>
+    <a:ext uri="{05A4C25C-085E-4340-85A3-A5531E510DB2}">
+      <thm15:themeFamily xmlns:thm15="http://schemas.microsoft.com/office/thememl/2012/main" name="Office Theme" id="{2E142A2C-CD16-42D6-873A-C26D2A0506FA}" vid="{1BDDFF52-6CD6-40A5-AB3C-68EB2F1E4D0A}"/>
+    </a:ext>
+  </a:extLst>
+</a:theme>
+</file>
+
+<file path=docMetadata/LabelInfo.xml><?xml version="1.0" encoding="utf-8"?>
+<clbl:labelList xmlns:clbl="http://schemas.microsoft.com/office/2020/mipLabelMetadata">
+  <clbl:label id="{37c354b2-85b0-47f5-b222-07b48d774ee3}" enabled="0" method="" siteId="{37c354b2-85b0-47f5-b222-07b48d774ee3}" removed="1"/>
+</clbl:labelList>
 </file>
</xml_diff>